<commit_message>
docs(apresentacao): refresh with the trimmed logo and a treatment note
Regenerates the deck against the re-cropped logo and mentions the
hour-23 shift classification fix on the data-treatment slide.
</commit_message>
<xml_diff>
--- a/docs/evidencias/AeroTrack-Apresentacao-Modulo6.pptx
+++ b/docs/evidencias/AeroTrack-Apresentacao-Modulo6.pptx
@@ -3264,7 +3264,7 @@
         <p:spPr>
           <a:xfrm>
             <a:off x="3566160" y="1965960"/>
-            <a:ext cx="4114800" cy="1005840"/>
+            <a:ext cx="3685286" cy="1005840"/>
           </a:xfrm>
           <a:prstGeom prst="rect">
             <a:avLst/>
@@ -8439,7 +8439,7 @@
         <p:spPr>
           <a:xfrm>
             <a:off x="3566160" y="2286000"/>
-            <a:ext cx="3740727" cy="914400"/>
+            <a:ext cx="3350260" cy="914400"/>
           </a:xfrm>
           <a:prstGeom prst="rect">
             <a:avLst/>
@@ -10752,11 +10752,11 @@
                 <a:spcPct val="115000"/>
               </a:lnSpc>
               <a:spcAft>
-                <a:spcPts val="1600"/>
+                <a:spcPts val="1400"/>
               </a:spcAft>
             </a:pPr>
             <a:r>
-              <a:rPr sz="1800">
+              <a:rPr sz="1700">
                 <a:solidFill>
                   <a:srgbClr val="26364A"/>
                 </a:solidFill>
@@ -10771,11 +10771,11 @@
                 <a:spcPct val="115000"/>
               </a:lnSpc>
               <a:spcAft>
-                <a:spcPts val="1600"/>
+                <a:spcPts val="1400"/>
               </a:spcAft>
             </a:pPr>
             <a:r>
-              <a:rPr sz="1800">
+              <a:rPr sz="1700">
                 <a:solidFill>
                   <a:srgbClr val="26364A"/>
                 </a:solidFill>
@@ -10790,11 +10790,11 @@
                 <a:spcPct val="115000"/>
               </a:lnSpc>
               <a:spcAft>
-                <a:spcPts val="1600"/>
+                <a:spcPts val="1400"/>
               </a:spcAft>
             </a:pPr>
             <a:r>
-              <a:rPr sz="1800">
+              <a:rPr sz="1700">
                 <a:solidFill>
                   <a:srgbClr val="26364A"/>
                 </a:solidFill>
@@ -10809,17 +10809,36 @@
                 <a:spcPct val="115000"/>
               </a:lnSpc>
               <a:spcAft>
-                <a:spcPts val="1600"/>
+                <a:spcPts val="1400"/>
               </a:spcAft>
             </a:pPr>
             <a:r>
-              <a:rPr sz="1800">
+              <a:rPr sz="1700">
                 <a:solidFill>
                   <a:srgbClr val="26364A"/>
                 </a:solidFill>
                 <a:latin typeface="Arial"/>
               </a:rPr>
               <a:t>•  CO and NO2 analytical classification (GOOD, MODERATE, CRITICAL): calibrated from the dataset's own percentiles, with no external regulatory reference</a:t>
+            </a:r>
+          </a:p>
+          <a:p>
+            <a:pPr>
+              <a:lnSpc>
+                <a:spcPct val="115000"/>
+              </a:lnSpc>
+              <a:spcAft>
+                <a:spcPts val="1400"/>
+              </a:spcAft>
+            </a:pPr>
+            <a:r>
+              <a:rPr sz="1700">
+                <a:solidFill>
+                  <a:srgbClr val="26364A"/>
+                </a:solidFill>
+                <a:latin typeface="Arial"/>
+              </a:rPr>
+              <a:t>•  Time-of-day boundary fix: the NOITE (evening) range excluded hour 23 until it was widened to include it</a:t>
             </a:r>
           </a:p>
         </p:txBody>

</xml_diff>

<commit_message>
docs(relatorio): shrink table font, fix remaining accents, use PT flowchart
Wraps every longtable in \small so the pipeline/database tables fit
more comfortably and read less cramped. Fixes several more missed
accents (resumo executivo, Janino description, dashboard section).
Swaps the architecture flowchart for a Portuguese-labeled version to
match the rest of the report.
</commit_message>
<xml_diff>
--- a/docs/evidencias/AeroTrack-Apresentacao-Modulo6.pptx
+++ b/docs/evidencias/AeroTrack-Apresentacao-Modulo6.pptx
@@ -3305,7 +3305,7 @@
                 </a:solidFill>
                 <a:latin typeface="Arial"/>
               </a:rPr>
-              <a:t>Air Quality Monitoring with Apache Hop</a:t>
+              <a:t>Monitoramento de Qualidade do Ar com Apache Hop</a:t>
             </a:r>
           </a:p>
         </p:txBody>
@@ -3344,7 +3344,7 @@
                 </a:solidFill>
                 <a:latin typeface="Arial"/>
               </a:rPr>
-              <a:t>Module 6 Final Project | Apache Hop</a:t>
+              <a:t>Trabalho Final do Módulo 6 | Apache Hop</a:t>
             </a:r>
           </a:p>
         </p:txBody>
@@ -3422,7 +3422,7 @@
                 </a:solidFill>
                 <a:latin typeface="Arial"/>
               </a:rPr>
-              <a:t>AI and Digital Transformation Program</a:t>
+              <a:t>Capacitação em IA e Transformação Digital</a:t>
             </a:r>
           </a:p>
         </p:txBody>
@@ -3531,7 +3531,7 @@
                 </a:solidFill>
                 <a:latin typeface="Arial"/>
               </a:rPr>
-              <a:t>PERSISTENCE</a:t>
+              <a:t>PERSISTÊNCIA</a:t>
             </a:r>
           </a:p>
         </p:txBody>
@@ -3570,7 +3570,7 @@
                 </a:solidFill>
                 <a:latin typeface="Arial"/>
               </a:rPr>
-              <a:t>Database and rerun safety</a:t>
+              <a:t>Banco de dados e segurança de reexecução</a:t>
             </a:r>
           </a:p>
         </p:txBody>
@@ -3718,7 +3718,7 @@
                 </a:solidFill>
                 <a:latin typeface="Arial"/>
               </a:rPr>
-              <a:t>Treated, detailed data, one row per valid reading</a:t>
+              <a:t>Dados tratados e detalhados, uma linha por leitura válida</a:t>
             </a:r>
           </a:p>
         </p:txBody>
@@ -3796,7 +3796,7 @@
                 </a:solidFill>
                 <a:latin typeface="Arial"/>
               </a:rPr>
-              <a:t>Readings with no reference pollutant</a:t>
+              <a:t>Leituras sem nenhum poluente de referência</a:t>
             </a:r>
           </a:p>
         </p:txBody>
@@ -3874,7 +3874,7 @@
                 </a:solidFill>
                 <a:latin typeface="Arial"/>
               </a:rPr>
-              <a:t>Indicators aggregated by day</a:t>
+              <a:t>Indicadores agregados por dia</a:t>
             </a:r>
           </a:p>
         </p:txBody>
@@ -3952,7 +3952,7 @@
                 </a:solidFill>
                 <a:latin typeface="Arial"/>
               </a:rPr>
-              <a:t>Indicators aggregated by month</a:t>
+              <a:t>Indicadores agregados por mês</a:t>
             </a:r>
           </a:p>
         </p:txBody>
@@ -4022,7 +4022,7 @@
                 </a:solidFill>
                 <a:latin typeface="Arial"/>
               </a:rPr>
-              <a:t>Rerun without duplicates</a:t>
+              <a:t>Reexecução sem duplicidade</a:t>
             </a:r>
           </a:p>
           <a:p>
@@ -4038,7 +4038,7 @@
                 </a:solidFill>
                 <a:latin typeface="Arial"/>
               </a:rPr>
-              <a:t>UNIQUE key on data_hora plus Insert/Update: rerunning the process updates existing records instead of duplicating. Validated by running the workflow twice in a row (8131 rows both times).</a:t>
+              <a:t>Chave UNIQUE em data_hora mais Insert/Update: reexecutar o processo atualiza os registros existentes em vez de duplicar. Validado executando o workflow duas vezes seguidas (8131 linhas nas duas execuções).</a:t>
             </a:r>
           </a:p>
         </p:txBody>
@@ -4077,7 +4077,7 @@
                 </a:solidFill>
                 <a:latin typeface="Arial"/>
               </a:rPr>
-              <a:t>AeroTrack | Module 6 | Apache Hop</a:t>
+              <a:t>AeroTrack | Módulo 6 | Apache Hop</a:t>
             </a:r>
           </a:p>
         </p:txBody>
@@ -4225,7 +4225,7 @@
                 </a:solidFill>
                 <a:latin typeface="Arial"/>
               </a:rPr>
-              <a:t>ANALYSIS</a:t>
+              <a:t>ANÁLISE</a:t>
             </a:r>
           </a:p>
         </p:txBody>
@@ -4264,7 +4264,7 @@
                 </a:solidFill>
                 <a:latin typeface="Arial"/>
               </a:rPr>
-              <a:t>Indicators calculated</a:t>
+              <a:t>Indicadores calculados</a:t>
             </a:r>
           </a:p>
         </p:txBody>
@@ -4376,7 +4376,7 @@
                 </a:solidFill>
                 <a:latin typeface="Arial"/>
               </a:rPr>
-              <a:t>•  Total treated and rejected readings</a:t>
+              <a:t>•  Total de leituras tratadas e rejeitadas</a:t>
             </a:r>
           </a:p>
           <a:p>
@@ -4395,7 +4395,7 @@
                 </a:solidFill>
                 <a:latin typeface="Arial"/>
               </a:rPr>
-              <a:t>•  Percentage of hours in critical condition</a:t>
+              <a:t>•  Percentual de horas em condição crítica</a:t>
             </a:r>
           </a:p>
           <a:p>
@@ -4414,7 +4414,7 @@
                 </a:solidFill>
                 <a:latin typeface="Arial"/>
               </a:rPr>
-              <a:t>•  Average and maximum CO and NO2</a:t>
+              <a:t>•  CO e NO2 médios e máximos</a:t>
             </a:r>
           </a:p>
           <a:p>
@@ -4433,7 +4433,7 @@
                 </a:solidFill>
                 <a:latin typeface="Arial"/>
               </a:rPr>
-              <a:t>•  Monthly trend of CO and NO2</a:t>
+              <a:t>•  Evolução mensal de CO e de NO2</a:t>
             </a:r>
           </a:p>
           <a:p>
@@ -4452,7 +4452,7 @@
                 </a:solidFill>
                 <a:latin typeface="Arial"/>
               </a:rPr>
-              <a:t>•  Distribution of readings by level (good, moderate, critical)</a:t>
+              <a:t>•  Distribuição das leituras por nível (bom, moderado, crítico)</a:t>
             </a:r>
           </a:p>
           <a:p>
@@ -4471,7 +4471,7 @@
                 </a:solidFill>
                 <a:latin typeface="Arial"/>
               </a:rPr>
-              <a:t>•  Readings by time of day</a:t>
+              <a:t>•  Leituras por turno do dia</a:t>
             </a:r>
           </a:p>
           <a:p>
@@ -4490,7 +4490,7 @@
                 </a:solidFill>
                 <a:latin typeface="Arial"/>
               </a:rPr>
-              <a:t>•  Ranking of the ten worst days</a:t>
+              <a:t>•  Ranking dos dez piores dias</a:t>
             </a:r>
           </a:p>
         </p:txBody>
@@ -4529,7 +4529,7 @@
                 </a:solidFill>
                 <a:latin typeface="Arial"/>
               </a:rPr>
-              <a:t>AeroTrack | Module 6 | Apache Hop</a:t>
+              <a:t>AeroTrack | Módulo 6 | Apache Hop</a:t>
             </a:r>
           </a:p>
         </p:txBody>
@@ -4677,7 +4677,7 @@
                 </a:solidFill>
                 <a:latin typeface="Arial"/>
               </a:rPr>
-              <a:t>VISUALIZATION</a:t>
+              <a:t>VISUALIZAÇÃO</a:t>
             </a:r>
           </a:p>
         </p:txBody>
@@ -4716,7 +4716,7 @@
                 </a:solidFill>
                 <a:latin typeface="Arial"/>
               </a:rPr>
-              <a:t>AeroTrack dashboard</a:t>
+              <a:t>Dashboard AeroTrack</a:t>
             </a:r>
           </a:p>
         </p:txBody>
@@ -4823,8 +4823,8 @@
         </p:nvSpPr>
         <p:spPr>
           <a:xfrm>
-            <a:off x="640080" y="6510528"/>
-            <a:ext cx="5486400" cy="274320"/>
+            <a:off x="822960" y="6355080"/>
+            <a:ext cx="10515600" cy="365760"/>
           </a:xfrm>
           <a:prstGeom prst="rect">
             <a:avLst/>
@@ -4843,20 +4843,59 @@
               </a:lnSpc>
             </a:pPr>
             <a:r>
+              <a:rPr sz="1100" b="0" i="1">
+                <a:solidFill>
+                  <a:srgbClr val="898781"/>
+                </a:solidFill>
+                <a:latin typeface="Arial"/>
+              </a:rPr>
+              <a:t>Interface do dashboard em inglês, junto com o restante do código do projeto.</a:t>
+            </a:r>
+          </a:p>
+        </p:txBody>
+      </p:sp>
+      <p:sp>
+        <p:nvSpPr>
+          <p:cNvPr id="9" name="TextBox 8"/>
+          <p:cNvSpPr txBox="1"/>
+          <p:nvPr/>
+        </p:nvSpPr>
+        <p:spPr>
+          <a:xfrm>
+            <a:off x="640080" y="6510528"/>
+            <a:ext cx="5486400" cy="274320"/>
+          </a:xfrm>
+          <a:prstGeom prst="rect">
+            <a:avLst/>
+          </a:prstGeom>
+          <a:noFill/>
+        </p:spPr>
+        <p:txBody>
+          <a:bodyPr wrap="square" anchor="t">
+            <a:spAutoFit/>
+          </a:bodyPr>
+          <a:lstStyle/>
+          <a:p>
+            <a:pPr algn="l">
+              <a:lnSpc>
+                <a:spcPct val="115000"/>
+              </a:lnSpc>
+            </a:pPr>
+            <a:r>
               <a:rPr sz="1000" b="0" i="0">
                 <a:solidFill>
                   <a:srgbClr val="898781"/>
                 </a:solidFill>
                 <a:latin typeface="Arial"/>
               </a:rPr>
-              <a:t>AeroTrack | Module 6 | Apache Hop</a:t>
-            </a:r>
-          </a:p>
-        </p:txBody>
-      </p:sp>
-      <p:sp>
-        <p:nvSpPr>
-          <p:cNvPr id="9" name="TextBox 8"/>
+              <a:t>AeroTrack | Módulo 6 | Apache Hop</a:t>
+            </a:r>
+          </a:p>
+        </p:txBody>
+      </p:sp>
+      <p:sp>
+        <p:nvSpPr>
+          <p:cNvPr id="10" name="TextBox 9"/>
           <p:cNvSpPr txBox="1"/>
           <p:nvPr/>
         </p:nvSpPr>
@@ -4997,7 +5036,7 @@
                 </a:solidFill>
                 <a:latin typeface="Arial"/>
               </a:rPr>
-              <a:t>ANSWERING THE QUESTION</a:t>
+              <a:t>RESPONDENDO À PERGUNTA</a:t>
             </a:r>
           </a:p>
         </p:txBody>
@@ -5036,7 +5075,7 @@
                 </a:solidFill>
                 <a:latin typeface="Arial"/>
               </a:rPr>
-              <a:t>Ranking of the ten worst days</a:t>
+              <a:t>Ranking dos dez piores dias</a:t>
             </a:r>
           </a:p>
         </p:txBody>
@@ -5169,7 +5208,7 @@
                 </a:solidFill>
                 <a:latin typeface="Arial"/>
               </a:rPr>
-              <a:t>AeroTrack | Module 6 | Apache Hop</a:t>
+              <a:t>AeroTrack | Módulo 6 | Apache Hop</a:t>
             </a:r>
           </a:p>
         </p:txBody>
@@ -5317,7 +5356,7 @@
                 </a:solidFill>
                 <a:latin typeface="Arial"/>
               </a:rPr>
-              <a:t>RESULTS</a:t>
+              <a:t>RESULTADOS</a:t>
             </a:r>
           </a:p>
         </p:txBody>
@@ -5356,7 +5395,7 @@
                 </a:solidFill>
                 <a:latin typeface="Arial"/>
               </a:rPr>
-              <a:t>Validation of results</a:t>
+              <a:t>Validação dos resultados</a:t>
             </a:r>
           </a:p>
         </p:txBody>
@@ -5520,7 +5559,7 @@
                 </a:solidFill>
                 <a:latin typeface="Arial"/>
               </a:rPr>
-              <a:t>TREATED READINGS</a:t>
+              <a:t>LEITURAS TRATADAS</a:t>
             </a:r>
           </a:p>
         </p:txBody>
@@ -5559,7 +5598,7 @@
                 </a:solidFill>
                 <a:latin typeface="Arial"/>
               </a:rPr>
-              <a:t>8,131</a:t>
+              <a:t>8.131</a:t>
             </a:r>
           </a:p>
         </p:txBody>
@@ -5653,7 +5692,7 @@
                 </a:solidFill>
                 <a:latin typeface="Arial"/>
               </a:rPr>
-              <a:t>REJECTED RECORDS</a:t>
+              <a:t>REGISTROS REJEITADOS</a:t>
             </a:r>
           </a:p>
         </p:txBody>
@@ -5692,7 +5731,7 @@
                 </a:solidFill>
                 <a:latin typeface="Arial"/>
               </a:rPr>
-              <a:t>1,226</a:t>
+              <a:t>1.226</a:t>
             </a:r>
           </a:p>
         </p:txBody>
@@ -5786,7 +5825,7 @@
                 </a:solidFill>
                 <a:latin typeface="Arial"/>
               </a:rPr>
-              <a:t>% CRITICAL HOURS</a:t>
+              <a:t>% HORAS CRÍTICAS</a:t>
             </a:r>
           </a:p>
         </p:txBody>
@@ -5825,7 +5864,7 @@
                 </a:solidFill>
                 <a:latin typeface="Arial"/>
               </a:rPr>
-              <a:t>13.11%</a:t>
+              <a:t>13,11%</a:t>
             </a:r>
           </a:p>
         </p:txBody>
@@ -5919,7 +5958,7 @@
                 </a:solidFill>
                 <a:latin typeface="Arial"/>
               </a:rPr>
-              <a:t>AVG. CO</a:t>
+              <a:t>CO MÉDIO</a:t>
             </a:r>
           </a:p>
         </p:txBody>
@@ -5958,7 +5997,7 @@
                 </a:solidFill>
                 <a:latin typeface="Arial"/>
               </a:rPr>
-              <a:t>2.15 mg/m3</a:t>
+              <a:t>2,15 mg/m3</a:t>
             </a:r>
           </a:p>
         </p:txBody>
@@ -6052,7 +6091,7 @@
                 </a:solidFill>
                 <a:latin typeface="Arial"/>
               </a:rPr>
-              <a:t>AVG. NO2</a:t>
+              <a:t>NO2 MÉDIO</a:t>
             </a:r>
           </a:p>
         </p:txBody>
@@ -6091,7 +6130,7 @@
                 </a:solidFill>
                 <a:latin typeface="Arial"/>
               </a:rPr>
-              <a:t>113.09 ug/m3</a:t>
+              <a:t>113,09 ug/m3</a:t>
             </a:r>
           </a:p>
         </p:txBody>
@@ -6185,7 +6224,7 @@
                 </a:solidFill>
                 <a:latin typeface="Arial"/>
               </a:rPr>
-              <a:t>DAYS CONSOLIDATED</a:t>
+              <a:t>DIAS CONSOLIDADOS</a:t>
             </a:r>
           </a:p>
         </p:txBody>
@@ -6287,7 +6326,7 @@
                 </a:solidFill>
                 <a:latin typeface="Arial"/>
               </a:rPr>
-              <a:t>Valid plus rejected readings match the dataset total after removing the 114 empty export rows. The</a:t>
+              <a:t>Leituras válidas mais rejeitadas batem com o total do dataset após remover as 114 linhas vazias do</a:t>
             </a:r>
           </a:p>
           <a:p>
@@ -6303,7 +6342,7 @@
                 </a:solidFill>
                 <a:latin typeface="Arial"/>
               </a:rPr>
-              <a:t>worst-day ranking shows high NO2 and a high critical-hour share on the same dates as the highest CO,</a:t>
+              <a:t>export. O ranking dos piores dias mostra NO2 e percentual de horas críticas elevados nas mesmas datas</a:t>
             </a:r>
           </a:p>
           <a:p>
@@ -6319,7 +6358,7 @@
                 </a:solidFill>
                 <a:latin typeface="Arial"/>
               </a:rPr>
-              <a:t>consistent with real pollutant behavior.</a:t>
+              <a:t>de maior CO, consistente com o comportamento real dos poluentes.</a:t>
             </a:r>
           </a:p>
         </p:txBody>
@@ -6358,7 +6397,7 @@
                 </a:solidFill>
                 <a:latin typeface="Arial"/>
               </a:rPr>
-              <a:t>AeroTrack | Module 6 | Apache Hop</a:t>
+              <a:t>AeroTrack | Módulo 6 | Apache Hop</a:t>
             </a:r>
           </a:p>
         </p:txBody>
@@ -6456,13 +6495,13 @@
               </a:lnSpc>
             </a:pPr>
             <a:r>
-              <a:rPr sz="3000" b="1" i="0">
+              <a:rPr sz="2900" b="1" i="0">
                 <a:solidFill>
                   <a:srgbClr val="FFFFFF"/>
                 </a:solidFill>
                 <a:latin typeface="Arial"/>
               </a:rPr>
-              <a:t>Every critical hour now has a record</a:t>
+              <a:t>Toda hora crítica agora tem um registro</a:t>
             </a:r>
           </a:p>
         </p:txBody>
@@ -6550,7 +6589,7 @@
                 </a:solidFill>
                 <a:latin typeface="Arial"/>
               </a:rPr>
-              <a:t>•  AeroTrack turns raw, noisy sensor exports into a database that can answer, with evidence, when air quality was worst</a:t>
+              <a:t>•  O AeroTrack transforma exports brutos e ruidosos em um banco capaz de responder, com evidência, quando a qualidade do ar foi pior</a:t>
             </a:r>
           </a:p>
           <a:p>
@@ -6569,7 +6608,7 @@
                 </a:solidFill>
                 <a:latin typeface="Arial"/>
               </a:rPr>
-              <a:t>•  The CO/NO2 classification was calibrated on the dataset's real distribution, not arbitrary thresholds</a:t>
+              <a:t>•  A classificação de CO/NO2 foi calibrada pela distribuição real do dataset, não por limites arbitrários</a:t>
             </a:r>
           </a:p>
           <a:p>
@@ -6588,7 +6627,7 @@
                 </a:solidFill>
                 <a:latin typeface="Arial"/>
               </a:rPr>
-              <a:t>•  Every table is safe to reload: Insert/Update guarantees no duplicate history, run after run</a:t>
+              <a:t>•  Toda tabela é segura para recarregar: Insert/Update garante nenhuma duplicidade, execução após execução</a:t>
             </a:r>
           </a:p>
         </p:txBody>
@@ -6627,7 +6666,7 @@
                 </a:solidFill>
                 <a:latin typeface="Arial"/>
               </a:rPr>
-              <a:t>AeroTrack | Module 6 | Apache Hop</a:t>
+              <a:t>AeroTrack | Módulo 6 | Apache Hop</a:t>
             </a:r>
           </a:p>
         </p:txBody>
@@ -6823,7 +6862,7 @@
                 </a:solidFill>
                 <a:latin typeface="Arial"/>
               </a:rPr>
-              <a:t>AeroTrack Team</a:t>
+              <a:t>Equipe AeroTrack</a:t>
             </a:r>
           </a:p>
         </p:txBody>
@@ -7220,7 +7259,7 @@
                 </a:solidFill>
                 <a:latin typeface="Arial"/>
               </a:rPr>
-              <a:t>Thank you</a:t>
+              <a:t>Obrigado</a:t>
             </a:r>
           </a:p>
         </p:txBody>
@@ -7303,13 +7342,13 @@
               </a:lnSpc>
             </a:pPr>
             <a:r>
-              <a:rPr sz="4000" b="1" i="0">
+              <a:rPr sz="3800" b="1" i="0">
                 <a:solidFill>
                   <a:srgbClr val="FFFFFF"/>
                 </a:solidFill>
                 <a:latin typeface="Arial"/>
               </a:rPr>
-              <a:t>You cannot see the air</a:t>
+              <a:t>Você não consegue ver o ar</a:t>
             </a:r>
           </a:p>
           <a:p>
@@ -7319,13 +7358,13 @@
               </a:lnSpc>
             </a:pPr>
             <a:r>
-              <a:rPr sz="4000" b="1" i="0">
+              <a:rPr sz="3800" b="1" i="0">
                 <a:solidFill>
                   <a:srgbClr val="FFFFFF"/>
                 </a:solidFill>
                 <a:latin typeface="Arial"/>
               </a:rPr>
-              <a:t>you breathe.</a:t>
+              <a:t>que respira.</a:t>
             </a:r>
           </a:p>
         </p:txBody>
@@ -7358,13 +7397,13 @@
               </a:lnSpc>
             </a:pPr>
             <a:r>
-              <a:rPr sz="1900" b="0" i="0">
+              <a:rPr sz="1800" b="0" i="0">
                 <a:solidFill>
                   <a:srgbClr val="CFE3F7"/>
                 </a:solidFill>
                 <a:latin typeface="Arial"/>
               </a:rPr>
-              <a:t>Air pollution is one of the world's largest environmental health risks.</a:t>
+              <a:t>A poluição do ar é um dos maiores riscos ambientais à saúde no mundo.</a:t>
             </a:r>
           </a:p>
           <a:p>
@@ -7374,13 +7413,13 @@
               </a:lnSpc>
             </a:pPr>
             <a:r>
-              <a:rPr sz="1900" b="0" i="0">
+              <a:rPr sz="1800" b="0" i="0">
                 <a:solidFill>
                   <a:srgbClr val="CFE3F7"/>
                 </a:solidFill>
                 <a:latin typeface="Arial"/>
               </a:rPr>
-              <a:t>CO and NO2 levels can spike for hours without anyone noticing,</a:t>
+              <a:t>Os níveis de CO e NO2 podem disparar por horas sem que ninguém perceba,</a:t>
             </a:r>
           </a:p>
           <a:p>
@@ -7390,13 +7429,13 @@
               </a:lnSpc>
             </a:pPr>
             <a:r>
-              <a:rPr sz="1900" b="0" i="0">
+              <a:rPr sz="1800" b="0" i="0">
                 <a:solidFill>
                   <a:srgbClr val="CFE3F7"/>
                 </a:solidFill>
                 <a:latin typeface="Arial"/>
               </a:rPr>
-              <a:t>until the exposure has already happened.</a:t>
+              <a:t>até que a exposição já tenha acontecido.</a:t>
             </a:r>
           </a:p>
         </p:txBody>
@@ -7482,13 +7521,13 @@
               </a:lnSpc>
             </a:pPr>
             <a:r>
-              <a:rPr sz="1700" b="0" i="1">
+              <a:rPr sz="1600" b="0" i="1">
                 <a:solidFill>
                   <a:srgbClr val="E8A300"/>
                 </a:solidFill>
                 <a:latin typeface="Arial"/>
               </a:rPr>
-              <a:t>The real question is not “is the air polluted”. It is: exactly WHEN was it</a:t>
+              <a:t>A pergunta real não é “o ar está poluído”. É: exatamente QUANDO ele esteve</a:t>
             </a:r>
           </a:p>
           <a:p>
@@ -7498,13 +7537,13 @@
               </a:lnSpc>
             </a:pPr>
             <a:r>
-              <a:rPr sz="1700" b="0" i="1">
+              <a:rPr sz="1600" b="0" i="1">
                 <a:solidFill>
                   <a:srgbClr val="E8A300"/>
                 </a:solidFill>
                 <a:latin typeface="Arial"/>
               </a:rPr>
-              <a:t>worst, and what conditions made it worse?</a:t>
+              <a:t>pior, e quais condições contribuíram para isso?</a:t>
             </a:r>
           </a:p>
         </p:txBody>
@@ -7543,7 +7582,7 @@
                 </a:solidFill>
                 <a:latin typeface="Arial"/>
               </a:rPr>
-              <a:t>AeroTrack | Module 6 | Apache Hop</a:t>
+              <a:t>AeroTrack | Módulo 6 | Apache Hop</a:t>
             </a:r>
           </a:p>
         </p:txBody>
@@ -7641,13 +7680,13 @@
               </a:lnSpc>
             </a:pPr>
             <a:r>
-              <a:rPr sz="2800" b="1" i="0">
+              <a:rPr sz="2700" b="1" i="0">
                 <a:solidFill>
                   <a:srgbClr val="FFFFFF"/>
                 </a:solidFill>
                 <a:latin typeface="Arial"/>
               </a:rPr>
-              <a:t>Without treated data, that question has no answer</a:t>
+              <a:t>Sem dados tratados, essa pergunta não tem resposta</a:t>
             </a:r>
           </a:p>
         </p:txBody>
@@ -7817,7 +7856,7 @@
                 </a:solidFill>
                 <a:latin typeface="Arial"/>
               </a:rPr>
-              <a:t>Raw sensor noise</a:t>
+              <a:t>Ruído do sensor bruto</a:t>
             </a:r>
           </a:p>
         </p:txBody>
@@ -7856,7 +7895,7 @@
                 </a:solidFill>
                 <a:latin typeface="Arial"/>
               </a:rPr>
-              <a:t>Missing readings, a -200 sentinel value and empty export rows hide the real signal.</a:t>
+              <a:t>Leituras ausentes, um valor sentinela -200 e linhas vazias do export escondem o sinal real.</a:t>
             </a:r>
           </a:p>
         </p:txBody>
@@ -7980,7 +8019,7 @@
                 </a:solidFill>
                 <a:latin typeface="Arial"/>
               </a:rPr>
-              <a:t>No structure</a:t>
+              <a:t>Sem estrutura</a:t>
             </a:r>
           </a:p>
         </p:txBody>
@@ -8019,7 +8058,7 @@
                 </a:solidFill>
                 <a:latin typeface="Arial"/>
               </a:rPr>
-              <a:t>Nothing tells you which hours, days or months were actually critical.</a:t>
+              <a:t>Nada indica quais horas, dias ou meses foram realmente críticos.</a:t>
             </a:r>
           </a:p>
         </p:txBody>
@@ -8143,7 +8182,7 @@
                 </a:solidFill>
                 <a:latin typeface="Arial"/>
               </a:rPr>
-              <a:t>No memory</a:t>
+              <a:t>Sem memória</a:t>
             </a:r>
           </a:p>
         </p:txBody>
@@ -8182,7 +8221,7 @@
                 </a:solidFill>
                 <a:latin typeface="Arial"/>
               </a:rPr>
-              <a:t>Without a database, every analysis starts from zero, every single time.</a:t>
+              <a:t>Sem um banco de dados, toda análise recomeça do zero, sempre.</a:t>
             </a:r>
           </a:p>
         </p:txBody>
@@ -8221,7 +8260,7 @@
                 </a:solidFill>
                 <a:latin typeface="Arial"/>
               </a:rPr>
-              <a:t>AeroTrack was built to close exactly this gap.</a:t>
+              <a:t>O AeroTrack foi criado exatamente para preencher essa lacuna.</a:t>
             </a:r>
           </a:p>
         </p:txBody>
@@ -8260,7 +8299,7 @@
                 </a:solidFill>
                 <a:latin typeface="Arial"/>
               </a:rPr>
-              <a:t>AeroTrack | Module 6 | Apache Hop</a:t>
+              <a:t>AeroTrack | Módulo 6 | Apache Hop</a:t>
             </a:r>
           </a:p>
         </p:txBody>
@@ -8474,13 +8513,13 @@
               </a:lnSpc>
             </a:pPr>
             <a:r>
-              <a:rPr sz="2000" b="0" i="0">
+              <a:rPr sz="1900" b="0" i="0">
                 <a:solidFill>
                   <a:srgbClr val="CFE3F7"/>
                 </a:solidFill>
                 <a:latin typeface="Arial"/>
               </a:rPr>
-              <a:t>From raw sensor data to a clear, trustworthy answer.</a:t>
+              <a:t>Do dado bruto do sensor a uma resposta clara e confiável.</a:t>
             </a:r>
           </a:p>
         </p:txBody>
@@ -8519,7 +8558,7 @@
                 </a:solidFill>
                 <a:latin typeface="Arial"/>
               </a:rPr>
-              <a:t>Built end to end with Apache Hop</a:t>
+              <a:t>Construído de ponta a ponta com Apache Hop</a:t>
             </a:r>
           </a:p>
         </p:txBody>
@@ -8558,7 +8597,7 @@
                 </a:solidFill>
                 <a:latin typeface="Arial"/>
               </a:rPr>
-              <a:t>AeroTrack | Module 6 | Apache Hop</a:t>
+              <a:t>AeroTrack | Módulo 6 | Apache Hop</a:t>
             </a:r>
           </a:p>
         </p:txBody>
@@ -8706,7 +8745,7 @@
                 </a:solidFill>
                 <a:latin typeface="Arial"/>
               </a:rPr>
-              <a:t>THE DATA</a:t>
+              <a:t>OS DADOS</a:t>
             </a:r>
           </a:p>
         </p:txBody>
@@ -8745,7 +8784,7 @@
                 </a:solidFill>
                 <a:latin typeface="Arial"/>
               </a:rPr>
-              <a:t>Dataset and problem statement</a:t>
+              <a:t>Dataset e problema</a:t>
             </a:r>
           </a:p>
         </p:txBody>
@@ -8876,7 +8915,7 @@
                 </a:solidFill>
                 <a:latin typeface="Arial"/>
               </a:rPr>
-              <a:t>•  Source: a monitoring station in an Italian city (De Vito et al.)</a:t>
+              <a:t>•  Origem: estação de monitoramento em uma cidade italiana (De Vito et al.)</a:t>
             </a:r>
           </a:p>
           <a:p>
@@ -8895,7 +8934,7 @@
                 </a:solidFill>
                 <a:latin typeface="Arial"/>
               </a:rPr>
-              <a:t>•  Period: March 2004 to February 2005</a:t>
+              <a:t>•  Período: março de 2004 a fevereiro de 2005</a:t>
             </a:r>
           </a:p>
           <a:p>
@@ -8914,7 +8953,7 @@
                 </a:solidFill>
                 <a:latin typeface="Arial"/>
               </a:rPr>
-              <a:t>•  Volume: 9357 hourly readings, 15 variables</a:t>
+              <a:t>•  Volume: 9357 leituras horárias, 15 variáveis</a:t>
             </a:r>
           </a:p>
         </p:txBody>
@@ -9014,7 +9053,7 @@
                 </a:solidFill>
                 <a:latin typeface="Arial"/>
               </a:rPr>
-              <a:t>PROBLEM</a:t>
+              <a:t>PROBLEMA</a:t>
             </a:r>
           </a:p>
         </p:txBody>
@@ -9053,7 +9092,7 @@
                 </a:solidFill>
                 <a:latin typeface="Arial"/>
               </a:rPr>
-              <a:t>In which periods were the worst air quality conditions recorded, and which environmental variables were associated with them?</a:t>
+              <a:t>Em quais períodos ocorreram as piores condições de qualidade do ar, e quais variáveis ambientais estavam associadas a esses períodos?</a:t>
             </a:r>
           </a:p>
         </p:txBody>
@@ -9092,7 +9131,7 @@
                 </a:solidFill>
                 <a:latin typeface="Arial"/>
               </a:rPr>
-              <a:t>AeroTrack | Module 6 | Apache Hop</a:t>
+              <a:t>AeroTrack | Módulo 6 | Apache Hop</a:t>
             </a:r>
           </a:p>
         </p:txBody>
@@ -9240,7 +9279,7 @@
                 </a:solidFill>
                 <a:latin typeface="Arial"/>
               </a:rPr>
-              <a:t>THE SOLUTION</a:t>
+              <a:t>A SOLUÇÃO</a:t>
             </a:r>
           </a:p>
         </p:txBody>
@@ -9279,7 +9318,7 @@
                 </a:solidFill>
                 <a:latin typeface="Arial"/>
               </a:rPr>
-              <a:t>End-to-end architecture</a:t>
+              <a:t>Arquitetura de ponta a ponta</a:t>
             </a:r>
           </a:p>
         </p:txBody>
@@ -9356,7 +9395,7 @@
       </p:pic>
       <p:pic>
         <p:nvPicPr>
-          <p:cNvPr id="7" name="Picture 6" descr="aerotrack-flowchart.png"/>
+          <p:cNvPr id="7" name="Picture 6" descr="aerotrack-flowchart-pt.png"/>
           <p:cNvPicPr>
             <a:picLocks noChangeAspect="1"/>
           </p:cNvPicPr>
@@ -9412,7 +9451,7 @@
                 </a:solidFill>
                 <a:latin typeface="Arial"/>
               </a:rPr>
-              <a:t>Two Apache Hop pipelines, orchestrated by a workflow: pl_01_ingestion_treatment and</a:t>
+              <a:t>Duas pipelines Apache Hop, orquestradas por um workflow: pl_01_ingestion_treatment e</a:t>
             </a:r>
           </a:p>
           <a:p>
@@ -9428,7 +9467,7 @@
                 </a:solidFill>
                 <a:latin typeface="Arial"/>
               </a:rPr>
-              <a:t>pl_02_indicator_consolidation, feeding a PostgreSQL database and a live dashboard.</a:t>
+              <a:t>pl_02_indicator_consolidation, alimentando um banco PostgreSQL e um dashboard.</a:t>
             </a:r>
           </a:p>
         </p:txBody>
@@ -9467,7 +9506,7 @@
                 </a:solidFill>
                 <a:latin typeface="Arial"/>
               </a:rPr>
-              <a:t>AeroTrack | Module 6 | Apache Hop</a:t>
+              <a:t>AeroTrack | Módulo 6 | Apache Hop</a:t>
             </a:r>
           </a:p>
         </p:txBody>
@@ -9654,7 +9693,7 @@
                 </a:solidFill>
                 <a:latin typeface="Arial"/>
               </a:rPr>
-              <a:t>Ingestion and treatment pipeline</a:t>
+              <a:t>Pipeline de ingestão e tratamento</a:t>
             </a:r>
           </a:p>
         </p:txBody>
@@ -9766,7 +9805,7 @@
                 </a:solidFill>
                 <a:latin typeface="Arial"/>
               </a:rPr>
-              <a:t>•  CSV Input reads the raw dataset (semicolon separator, comma decimal)</a:t>
+              <a:t>•  CSV Input lê o dataset bruto (separador ponto e vírgula, decimal com vírgula)</a:t>
             </a:r>
           </a:p>
           <a:p>
@@ -9785,7 +9824,7 @@
                 </a:solidFill>
                 <a:latin typeface="Arial"/>
               </a:rPr>
-              <a:t>•  Filter Rows removes the empty rows left by the dataset export</a:t>
+              <a:t>•  Filter Rows remove as linhas vazias deixadas pelo export do dataset</a:t>
             </a:r>
           </a:p>
           <a:p>
@@ -9804,7 +9843,7 @@
                 </a:solidFill>
                 <a:latin typeface="Arial"/>
               </a:rPr>
-              <a:t>•  Formula builds a single date-time text; Null If handles the -200 missing-value sentinel</a:t>
+              <a:t>•  Formula monta um único texto de data e hora; Null If trata o sentinela -200</a:t>
             </a:r>
           </a:p>
           <a:p>
@@ -9823,7 +9862,7 @@
                 </a:solidFill>
                 <a:latin typeface="Arial"/>
               </a:rPr>
-              <a:t>•  Select Values renames fields and converts text into a proper Date</a:t>
+              <a:t>•  Select Values renomeia os campos e converte o texto em um tipo Data</a:t>
             </a:r>
           </a:p>
           <a:p>
@@ -9842,7 +9881,7 @@
                 </a:solidFill>
                 <a:latin typeface="Arial"/>
               </a:rPr>
-              <a:t>•  Calculator, Value Mapper and Number Range derive year, month, time of day and CO/NO2 level</a:t>
+              <a:t>•  Calculator, Value Mapper e Number Range derivam ano, mês, turno e o nível de CO/NO2</a:t>
             </a:r>
           </a:p>
           <a:p>
@@ -9861,7 +9900,7 @@
                 </a:solidFill>
                 <a:latin typeface="Arial"/>
               </a:rPr>
-              <a:t>•  Janino flags whether a reading is valid; Filter Rows splits valid from rejected readings</a:t>
+              <a:t>•  Janino calcula se a leitura é válida; Filter Rows separa leituras válidas das rejeitadas</a:t>
             </a:r>
           </a:p>
           <a:p>
@@ -9880,7 +9919,7 @@
                 </a:solidFill>
                 <a:latin typeface="Arial"/>
               </a:rPr>
-              <a:t>•  Insert/Update loads PostgreSQL keyed on data_hora, safe to rerun</a:t>
+              <a:t>•  Insert/Update grava no PostgreSQL com chave em data_hora, seguro para reexecutar</a:t>
             </a:r>
           </a:p>
         </p:txBody>
@@ -9919,7 +9958,7 @@
                 </a:solidFill>
                 <a:latin typeface="Arial"/>
               </a:rPr>
-              <a:t>AeroTrack | Module 6 | Apache Hop</a:t>
+              <a:t>AeroTrack | Módulo 6 | Apache Hop</a:t>
             </a:r>
           </a:p>
         </p:txBody>
@@ -10106,7 +10145,7 @@
                 </a:solidFill>
                 <a:latin typeface="Arial"/>
               </a:rPr>
-              <a:t>Consolidation pipeline and orchestration</a:t>
+              <a:t>Pipeline de consolidação e orquestração</a:t>
             </a:r>
           </a:p>
         </p:txBody>
@@ -10257,7 +10296,7 @@
                 </a:solidFill>
                 <a:latin typeface="Arial"/>
               </a:rPr>
-              <a:t>•  Table Input aggregates treated readings by day and by month</a:t>
+              <a:t>•  Table Input agrega as leituras tratadas por dia e por mês</a:t>
             </a:r>
           </a:p>
           <a:p>
@@ -10276,7 +10315,7 @@
                 </a:solidFill>
                 <a:latin typeface="Arial"/>
               </a:rPr>
-              <a:t>•  Insert/Update writes resumo_diario_qualidade_ar and resumo_mensal_qualidade_ar</a:t>
+              <a:t>•  Insert/Update grava resumo_diario_qualidade_ar e resumo_mensal_qualidade_ar</a:t>
             </a:r>
           </a:p>
         </p:txBody>
@@ -10379,13 +10418,13 @@
           <a:p>
             <a:pPr algn="ctr"/>
             <a:r>
-              <a:rPr sz="1600" b="1">
+              <a:rPr sz="1500" b="1">
                 <a:solidFill>
                   <a:srgbClr val="FFFFFF"/>
                 </a:solidFill>
                 <a:latin typeface="Consolas"/>
               </a:rPr>
-              <a:t>START  →  Ingestion and treatment  →  Indicator consolidation  →  Process completed</a:t>
+              <a:t>START  →  Ingestão e tratamento  →  Consolidação de indicadores  →  Processo concluído</a:t>
             </a:r>
           </a:p>
         </p:txBody>
@@ -10424,7 +10463,7 @@
                 </a:solidFill>
                 <a:latin typeface="Arial"/>
               </a:rPr>
-              <a:t>The second hop only runs if ingestion succeeds, preventing indicators from ever being built on an incomplete load.</a:t>
+              <a:t>O segundo hop só é seguido se a ingestão terminar com sucesso, evitando consolidar indicadores a partir de uma carga incompleta.</a:t>
             </a:r>
           </a:p>
         </p:txBody>
@@ -10463,7 +10502,7 @@
                 </a:solidFill>
                 <a:latin typeface="Arial"/>
               </a:rPr>
-              <a:t>AeroTrack | Module 6 | Apache Hop</a:t>
+              <a:t>AeroTrack | Módulo 6 | Apache Hop</a:t>
             </a:r>
           </a:p>
         </p:txBody>
@@ -10611,7 +10650,7 @@
                 </a:solidFill>
                 <a:latin typeface="Arial"/>
               </a:rPr>
-              <a:t>DATA QUALITY</a:t>
+              <a:t>QUALIDADE DE DADOS</a:t>
             </a:r>
           </a:p>
         </p:txBody>
@@ -10650,7 +10689,7 @@
                 </a:solidFill>
                 <a:latin typeface="Arial"/>
               </a:rPr>
-              <a:t>Treatments applied</a:t>
+              <a:t>Tratamentos aplicados</a:t>
             </a:r>
           </a:p>
         </p:txBody>
@@ -10762,7 +10801,7 @@
                 </a:solidFill>
                 <a:latin typeface="Arial"/>
               </a:rPr>
-              <a:t>•  -200 sentinel: converted to null before any calculation (Null If)</a:t>
+              <a:t>•  Sentinela -200: convertido em nulo antes de qualquer cálculo (Null If)</a:t>
             </a:r>
           </a:p>
           <a:p>
@@ -10781,7 +10820,7 @@
                 </a:solidFill>
                 <a:latin typeface="Arial"/>
               </a:rPr>
-              <a:t>•  114 empty export rows: dropped during ingestion (Filter Rows)</a:t>
+              <a:t>•  114 linhas vazias do export: descartadas na ingestão (Filter Rows)</a:t>
             </a:r>
           </a:p>
           <a:p>
@@ -10800,7 +10839,7 @@
                 </a:solidFill>
                 <a:latin typeface="Arial"/>
               </a:rPr>
-              <a:t>•  Readings with no reference pollutant (CO, NOx and NO2): separated into leituras_rejeitadas</a:t>
+              <a:t>•  Leituras sem nenhum poluente de referência (CO, NOx e NO2): separadas em leituras_rejeitadas</a:t>
             </a:r>
           </a:p>
           <a:p>
@@ -10819,7 +10858,7 @@
                 </a:solidFill>
                 <a:latin typeface="Arial"/>
               </a:rPr>
-              <a:t>•  CO and NO2 analytical classification (GOOD, MODERATE, CRITICAL): calibrated from the dataset's own percentiles, with no external regulatory reference</a:t>
+              <a:t>•  Classificação analítica de CO e NO2 (BOM, MODERADO, CRÍTICO): calibrada pelos percentis do próprio dataset, sem referência regulatória externa</a:t>
             </a:r>
           </a:p>
           <a:p>
@@ -10838,7 +10877,7 @@
                 </a:solidFill>
                 <a:latin typeface="Arial"/>
               </a:rPr>
-              <a:t>•  Time-of-day boundary fix: the NOITE (evening) range excluded hour 23 until it was widened to include it</a:t>
+              <a:t>•  Correção de limite: a faixa NOITE excluía a hora 23 até ser ampliada para incluí-la</a:t>
             </a:r>
           </a:p>
         </p:txBody>
@@ -10877,7 +10916,7 @@
                 </a:solidFill>
                 <a:latin typeface="Arial"/>
               </a:rPr>
-              <a:t>AeroTrack | Module 6 | Apache Hop</a:t>
+              <a:t>AeroTrack | Módulo 6 | Apache Hop</a:t>
             </a:r>
           </a:p>
         </p:txBody>

</xml_diff>

<commit_message>
docs(apresentacao): center the logo, add demo and report-preview slides
The logo was left-shifted on the cover and solution-reveal slides
because its placement math used the old (wider) logo aspect ratio;
recomputes the centered x position for the current crop.

Adds slide 11, "Demonstração ao vivo", cueing the presenter to switch
to Hop Designer and run the pipelines/workflow live, and slide 17, a
preview of the development report's executive summary page with a
pointer to the full PDF, placed right before the closing team slide.
</commit_message>
<xml_diff>
--- a/docs/evidencias/AeroTrack-Apresentacao-Modulo6.pptx
+++ b/docs/evidencias/AeroTrack-Apresentacao-Modulo6.pptx
@@ -21,6 +21,8 @@
     <p:sldId id="269" r:id="rId20"/>
     <p:sldId id="270" r:id="rId21"/>
     <p:sldId id="271" r:id="rId22"/>
+    <p:sldId id="272" r:id="rId23"/>
+    <p:sldId id="273" r:id="rId24"/>
   </p:sldIdLst>
   <p:sldSz cx="12191695" cy="6858000" type="screen4x3"/>
   <p:notesSz cx="6858000" cy="9144000"/>
@@ -3263,7 +3265,7 @@
         </p:blipFill>
         <p:spPr>
           <a:xfrm>
-            <a:off x="3566160" y="1965960"/>
+            <a:off x="4252874" y="1965960"/>
             <a:ext cx="3685286" cy="1005840"/>
           </a:xfrm>
           <a:prstGeom prst="rect">
@@ -4135,7 +4137,7 @@
     <p:bg>
       <p:bgPr>
         <a:solidFill>
-          <a:srgbClr val="FFFFFF"/>
+          <a:srgbClr val="0B1F33"/>
         </a:solidFill>
         <a:effectLst/>
       </p:bgPr>
@@ -4147,177 +4149,9 @@
         <p:nvPr/>
       </p:nvGrpSpPr>
       <p:grpSpPr/>
-      <p:sp>
-        <p:nvSpPr>
-          <p:cNvPr id="2" name="Rectangle 1"/>
-          <p:cNvSpPr/>
-          <p:nvPr/>
-        </p:nvSpPr>
-        <p:spPr>
-          <a:xfrm>
-            <a:off x="0" y="0"/>
-            <a:ext cx="12191695" cy="128016"/>
-          </a:xfrm>
-          <a:prstGeom prst="rect">
-            <a:avLst/>
-          </a:prstGeom>
-          <a:solidFill>
-            <a:srgbClr val="2A78D6"/>
-          </a:solidFill>
-          <a:ln>
-            <a:noFill/>
-          </a:ln>
-          <a:effectLst/>
-        </p:spPr>
-        <p:style>
-          <a:lnRef idx="1">
-            <a:schemeClr val="accent1"/>
-          </a:lnRef>
-          <a:fillRef idx="3">
-            <a:schemeClr val="accent1"/>
-          </a:fillRef>
-          <a:effectRef idx="2">
-            <a:schemeClr val="accent1"/>
-          </a:effectRef>
-          <a:fontRef idx="minor">
-            <a:schemeClr val="lt1"/>
-          </a:fontRef>
-        </p:style>
-        <p:txBody>
-          <a:bodyPr rtlCol="0" anchor="ctr"/>
-          <a:lstStyle/>
-          <a:p>
-            <a:pPr algn="ctr"/>
-          </a:p>
-        </p:txBody>
-      </p:sp>
-      <p:sp>
-        <p:nvSpPr>
-          <p:cNvPr id="3" name="TextBox 2"/>
-          <p:cNvSpPr txBox="1"/>
-          <p:nvPr/>
-        </p:nvSpPr>
-        <p:spPr>
-          <a:xfrm>
-            <a:off x="640080" y="292608"/>
-            <a:ext cx="8686800" cy="365760"/>
-          </a:xfrm>
-          <a:prstGeom prst="rect">
-            <a:avLst/>
-          </a:prstGeom>
-          <a:noFill/>
-        </p:spPr>
-        <p:txBody>
-          <a:bodyPr wrap="square" anchor="t">
-            <a:spAutoFit/>
-          </a:bodyPr>
-          <a:lstStyle/>
-          <a:p>
-            <a:pPr algn="l">
-              <a:lnSpc>
-                <a:spcPct val="115000"/>
-              </a:lnSpc>
-            </a:pPr>
-            <a:r>
-              <a:rPr sz="1400" b="1" i="0">
-                <a:solidFill>
-                  <a:srgbClr val="1BAF7A"/>
-                </a:solidFill>
-                <a:latin typeface="Arial"/>
-              </a:rPr>
-              <a:t>ANÁLISE</a:t>
-            </a:r>
-          </a:p>
-        </p:txBody>
-      </p:sp>
-      <p:sp>
-        <p:nvSpPr>
-          <p:cNvPr id="4" name="TextBox 3"/>
-          <p:cNvSpPr txBox="1"/>
-          <p:nvPr/>
-        </p:nvSpPr>
-        <p:spPr>
-          <a:xfrm>
-            <a:off x="640080" y="594360"/>
-            <a:ext cx="10789920" cy="822960"/>
-          </a:xfrm>
-          <a:prstGeom prst="rect">
-            <a:avLst/>
-          </a:prstGeom>
-          <a:noFill/>
-        </p:spPr>
-        <p:txBody>
-          <a:bodyPr wrap="square" anchor="t">
-            <a:spAutoFit/>
-          </a:bodyPr>
-          <a:lstStyle/>
-          <a:p>
-            <a:pPr algn="l">
-              <a:lnSpc>
-                <a:spcPct val="115000"/>
-              </a:lnSpc>
-            </a:pPr>
-            <a:r>
-              <a:rPr sz="2900" b="1" i="0">
-                <a:solidFill>
-                  <a:srgbClr val="0B1F33"/>
-                </a:solidFill>
-                <a:latin typeface="Arial"/>
-              </a:rPr>
-              <a:t>Indicadores calculados</a:t>
-            </a:r>
-          </a:p>
-        </p:txBody>
-      </p:sp>
-      <p:sp>
-        <p:nvSpPr>
-          <p:cNvPr id="5" name="Rounded Rectangle 4"/>
-          <p:cNvSpPr/>
-          <p:nvPr/>
-        </p:nvSpPr>
-        <p:spPr>
-          <a:xfrm>
-            <a:off x="658368" y="1261872"/>
-            <a:ext cx="1188720" cy="50800"/>
-          </a:xfrm>
-          <a:prstGeom prst="roundRect">
-            <a:avLst>
-              <a:gd name="adj" fmla="val 50000"/>
-            </a:avLst>
-          </a:prstGeom>
-          <a:solidFill>
-            <a:srgbClr val="1BAF7A"/>
-          </a:solidFill>
-          <a:ln>
-            <a:noFill/>
-          </a:ln>
-          <a:effectLst/>
-        </p:spPr>
-        <p:style>
-          <a:lnRef idx="1">
-            <a:schemeClr val="accent1"/>
-          </a:lnRef>
-          <a:fillRef idx="3">
-            <a:schemeClr val="accent1"/>
-          </a:fillRef>
-          <a:effectRef idx="2">
-            <a:schemeClr val="accent1"/>
-          </a:effectRef>
-          <a:fontRef idx="minor">
-            <a:schemeClr val="lt1"/>
-          </a:fontRef>
-        </p:style>
-        <p:txBody>
-          <a:bodyPr rtlCol="0" anchor="ctr"/>
-          <a:lstStyle/>
-          <a:p>
-            <a:pPr algn="ctr"/>
-          </a:p>
-        </p:txBody>
-      </p:sp>
       <p:pic>
         <p:nvPicPr>
-          <p:cNvPr id="6" name="Picture 5" descr="aerotrack-icon.png"/>
+          <p:cNvPr id="2" name="Picture 1" descr="icon_check.png"/>
           <p:cNvPicPr>
             <a:picLocks noChangeAspect="1"/>
           </p:cNvPicPr>
@@ -4331,14 +4165,263 @@
         </p:blipFill>
         <p:spPr>
           <a:xfrm>
-            <a:off x="11292840" y="274320"/>
-            <a:ext cx="502920" cy="502920"/>
+            <a:off x="822960" y="1005840"/>
+            <a:ext cx="1188720" cy="1188720"/>
           </a:xfrm>
           <a:prstGeom prst="rect">
             <a:avLst/>
           </a:prstGeom>
         </p:spPr>
       </p:pic>
+      <p:sp>
+        <p:nvSpPr>
+          <p:cNvPr id="3" name="TextBox 2"/>
+          <p:cNvSpPr txBox="1"/>
+          <p:nvPr/>
+        </p:nvSpPr>
+        <p:spPr>
+          <a:xfrm>
+            <a:off x="2286000" y="1051560"/>
+            <a:ext cx="9144000" cy="1097280"/>
+          </a:xfrm>
+          <a:prstGeom prst="rect">
+            <a:avLst/>
+          </a:prstGeom>
+          <a:noFill/>
+        </p:spPr>
+        <p:txBody>
+          <a:bodyPr wrap="square" anchor="t">
+            <a:spAutoFit/>
+          </a:bodyPr>
+          <a:lstStyle/>
+          <a:p>
+            <a:pPr algn="l">
+              <a:lnSpc>
+                <a:spcPct val="115000"/>
+              </a:lnSpc>
+            </a:pPr>
+            <a:r>
+              <a:rPr sz="3800" b="1" i="0">
+                <a:solidFill>
+                  <a:srgbClr val="FFFFFF"/>
+                </a:solidFill>
+                <a:latin typeface="Arial"/>
+              </a:rPr>
+              <a:t>Demonstração ao vivo</a:t>
+            </a:r>
+          </a:p>
+        </p:txBody>
+      </p:sp>
+      <p:sp>
+        <p:nvSpPr>
+          <p:cNvPr id="4" name="TextBox 3"/>
+          <p:cNvSpPr txBox="1"/>
+          <p:nvPr/>
+        </p:nvSpPr>
+        <p:spPr>
+          <a:xfrm>
+            <a:off x="2304288" y="1965960"/>
+            <a:ext cx="9052560" cy="548640"/>
+          </a:xfrm>
+          <a:prstGeom prst="rect">
+            <a:avLst/>
+          </a:prstGeom>
+          <a:noFill/>
+        </p:spPr>
+        <p:txBody>
+          <a:bodyPr wrap="square" anchor="t">
+            <a:spAutoFit/>
+          </a:bodyPr>
+          <a:lstStyle/>
+          <a:p>
+            <a:pPr algn="l">
+              <a:lnSpc>
+                <a:spcPct val="115000"/>
+              </a:lnSpc>
+            </a:pPr>
+            <a:r>
+              <a:rPr sz="1900" b="1" i="0">
+                <a:solidFill>
+                  <a:srgbClr val="E8A300"/>
+                </a:solidFill>
+                <a:latin typeface="Arial"/>
+              </a:rPr>
+              <a:t>Agora, direto no Apache Hop Designer</a:t>
+            </a:r>
+          </a:p>
+        </p:txBody>
+      </p:sp>
+      <p:sp>
+        <p:nvSpPr>
+          <p:cNvPr id="5" name="Rounded Rectangle 4"/>
+          <p:cNvSpPr/>
+          <p:nvPr/>
+        </p:nvSpPr>
+        <p:spPr>
+          <a:xfrm>
+            <a:off x="822960" y="2880360"/>
+            <a:ext cx="10515600" cy="2880360"/>
+          </a:xfrm>
+          <a:prstGeom prst="roundRect">
+            <a:avLst>
+              <a:gd name="adj" fmla="val 10000"/>
+            </a:avLst>
+          </a:prstGeom>
+          <a:solidFill>
+            <a:srgbClr val="162E4A"/>
+          </a:solidFill>
+          <a:ln>
+            <a:noFill/>
+          </a:ln>
+          <a:effectLst/>
+          <a:effectLst>
+            <a:outerShdw blurRad="180000" dist="45000" dir="5400000" rotWithShape="0">
+              <a:srgbClr val="0B1F33">
+                <a:alpha val="72000"/>
+              </a:srgbClr>
+            </a:outerShdw>
+          </a:effectLst>
+        </p:spPr>
+        <p:style>
+          <a:lnRef idx="1">
+            <a:schemeClr val="accent1"/>
+          </a:lnRef>
+          <a:fillRef idx="3">
+            <a:schemeClr val="accent1"/>
+          </a:fillRef>
+          <a:effectRef idx="2">
+            <a:schemeClr val="accent1"/>
+          </a:effectRef>
+          <a:fontRef idx="minor">
+            <a:schemeClr val="lt1"/>
+          </a:fontRef>
+        </p:style>
+        <p:txBody>
+          <a:bodyPr rtlCol="0" anchor="ctr"/>
+          <a:lstStyle/>
+          <a:p>
+            <a:pPr algn="ctr"/>
+          </a:p>
+        </p:txBody>
+      </p:sp>
+      <p:sp>
+        <p:nvSpPr>
+          <p:cNvPr id="6" name="TextBox 5"/>
+          <p:cNvSpPr txBox="1"/>
+          <p:nvPr/>
+        </p:nvSpPr>
+        <p:spPr>
+          <a:xfrm>
+            <a:off x="1188720" y="3200400"/>
+            <a:ext cx="9784080" cy="2468880"/>
+          </a:xfrm>
+          <a:prstGeom prst="rect">
+            <a:avLst/>
+          </a:prstGeom>
+          <a:noFill/>
+        </p:spPr>
+        <p:txBody>
+          <a:bodyPr wrap="square">
+            <a:spAutoFit/>
+          </a:bodyPr>
+          <a:lstStyle/>
+          <a:p>
+            <a:pPr>
+              <a:lnSpc>
+                <a:spcPct val="115000"/>
+              </a:lnSpc>
+              <a:spcAft>
+                <a:spcPts val="1400"/>
+              </a:spcAft>
+            </a:pPr>
+            <a:r>
+              <a:rPr sz="1700">
+                <a:solidFill>
+                  <a:srgbClr val="CFE3F7"/>
+                </a:solidFill>
+                <a:latin typeface="Arial"/>
+              </a:rPr>
+              <a:t>•  Abertura do projeto aerotrack no Hop Designer</a:t>
+            </a:r>
+          </a:p>
+          <a:p>
+            <a:pPr>
+              <a:lnSpc>
+                <a:spcPct val="115000"/>
+              </a:lnSpc>
+              <a:spcAft>
+                <a:spcPts val="1400"/>
+              </a:spcAft>
+            </a:pPr>
+            <a:r>
+              <a:rPr sz="1700">
+                <a:solidFill>
+                  <a:srgbClr val="CFE3F7"/>
+                </a:solidFill>
+                <a:latin typeface="Arial"/>
+              </a:rPr>
+              <a:t>•  Canvas de pl_01_ingestion_treatment: ingestão, tratamento e classificação</a:t>
+            </a:r>
+          </a:p>
+          <a:p>
+            <a:pPr>
+              <a:lnSpc>
+                <a:spcPct val="115000"/>
+              </a:lnSpc>
+              <a:spcAft>
+                <a:spcPts val="1400"/>
+              </a:spcAft>
+            </a:pPr>
+            <a:r>
+              <a:rPr sz="1700">
+                <a:solidFill>
+                  <a:srgbClr val="CFE3F7"/>
+                </a:solidFill>
+                <a:latin typeface="Arial"/>
+              </a:rPr>
+              <a:t>•  Canvas de pl_02_indicator_consolidation: resumos diário e mensal</a:t>
+            </a:r>
+          </a:p>
+          <a:p>
+            <a:pPr>
+              <a:lnSpc>
+                <a:spcPct val="115000"/>
+              </a:lnSpc>
+              <a:spcAft>
+                <a:spcPts val="1400"/>
+              </a:spcAft>
+            </a:pPr>
+            <a:r>
+              <a:rPr sz="1700">
+                <a:solidFill>
+                  <a:srgbClr val="CFE3F7"/>
+                </a:solidFill>
+                <a:latin typeface="Arial"/>
+              </a:rPr>
+              <a:t>•  Execução de wf_air_quality_orchestration de ponta a ponta, ao vivo</a:t>
+            </a:r>
+          </a:p>
+          <a:p>
+            <a:pPr>
+              <a:lnSpc>
+                <a:spcPct val="115000"/>
+              </a:lnSpc>
+              <a:spcAft>
+                <a:spcPts val="1400"/>
+              </a:spcAft>
+            </a:pPr>
+            <a:r>
+              <a:rPr sz="1700">
+                <a:solidFill>
+                  <a:srgbClr val="CFE3F7"/>
+                </a:solidFill>
+                <a:latin typeface="Arial"/>
+              </a:rPr>
+              <a:t>•  Conferência do resultado direto no PostgreSQL</a:t>
+            </a:r>
+          </a:p>
+        </p:txBody>
+      </p:sp>
       <p:sp>
         <p:nvSpPr>
           <p:cNvPr id="7" name="TextBox 6"/>
@@ -4347,162 +4430,6 @@
         </p:nvSpPr>
         <p:spPr>
           <a:xfrm>
-            <a:off x="822960" y="1737360"/>
-            <a:ext cx="10607040" cy="4389120"/>
-          </a:xfrm>
-          <a:prstGeom prst="rect">
-            <a:avLst/>
-          </a:prstGeom>
-          <a:noFill/>
-        </p:spPr>
-        <p:txBody>
-          <a:bodyPr wrap="square">
-            <a:spAutoFit/>
-          </a:bodyPr>
-          <a:lstStyle/>
-          <a:p>
-            <a:pPr>
-              <a:lnSpc>
-                <a:spcPct val="115000"/>
-              </a:lnSpc>
-              <a:spcAft>
-                <a:spcPts val="1300"/>
-              </a:spcAft>
-            </a:pPr>
-            <a:r>
-              <a:rPr sz="1800">
-                <a:solidFill>
-                  <a:srgbClr val="26364A"/>
-                </a:solidFill>
-                <a:latin typeface="Arial"/>
-              </a:rPr>
-              <a:t>•  Total de leituras tratadas e rejeitadas</a:t>
-            </a:r>
-          </a:p>
-          <a:p>
-            <a:pPr>
-              <a:lnSpc>
-                <a:spcPct val="115000"/>
-              </a:lnSpc>
-              <a:spcAft>
-                <a:spcPts val="1300"/>
-              </a:spcAft>
-            </a:pPr>
-            <a:r>
-              <a:rPr sz="1800">
-                <a:solidFill>
-                  <a:srgbClr val="26364A"/>
-                </a:solidFill>
-                <a:latin typeface="Arial"/>
-              </a:rPr>
-              <a:t>•  Percentual de horas em condição crítica</a:t>
-            </a:r>
-          </a:p>
-          <a:p>
-            <a:pPr>
-              <a:lnSpc>
-                <a:spcPct val="115000"/>
-              </a:lnSpc>
-              <a:spcAft>
-                <a:spcPts val="1300"/>
-              </a:spcAft>
-            </a:pPr>
-            <a:r>
-              <a:rPr sz="1800">
-                <a:solidFill>
-                  <a:srgbClr val="26364A"/>
-                </a:solidFill>
-                <a:latin typeface="Arial"/>
-              </a:rPr>
-              <a:t>•  CO e NO2 médios e máximos</a:t>
-            </a:r>
-          </a:p>
-          <a:p>
-            <a:pPr>
-              <a:lnSpc>
-                <a:spcPct val="115000"/>
-              </a:lnSpc>
-              <a:spcAft>
-                <a:spcPts val="1300"/>
-              </a:spcAft>
-            </a:pPr>
-            <a:r>
-              <a:rPr sz="1800">
-                <a:solidFill>
-                  <a:srgbClr val="26364A"/>
-                </a:solidFill>
-                <a:latin typeface="Arial"/>
-              </a:rPr>
-              <a:t>•  Evolução mensal de CO e de NO2</a:t>
-            </a:r>
-          </a:p>
-          <a:p>
-            <a:pPr>
-              <a:lnSpc>
-                <a:spcPct val="115000"/>
-              </a:lnSpc>
-              <a:spcAft>
-                <a:spcPts val="1300"/>
-              </a:spcAft>
-            </a:pPr>
-            <a:r>
-              <a:rPr sz="1800">
-                <a:solidFill>
-                  <a:srgbClr val="26364A"/>
-                </a:solidFill>
-                <a:latin typeface="Arial"/>
-              </a:rPr>
-              <a:t>•  Distribuição das leituras por nível (bom, moderado, crítico)</a:t>
-            </a:r>
-          </a:p>
-          <a:p>
-            <a:pPr>
-              <a:lnSpc>
-                <a:spcPct val="115000"/>
-              </a:lnSpc>
-              <a:spcAft>
-                <a:spcPts val="1300"/>
-              </a:spcAft>
-            </a:pPr>
-            <a:r>
-              <a:rPr sz="1800">
-                <a:solidFill>
-                  <a:srgbClr val="26364A"/>
-                </a:solidFill>
-                <a:latin typeface="Arial"/>
-              </a:rPr>
-              <a:t>•  Leituras por turno do dia</a:t>
-            </a:r>
-          </a:p>
-          <a:p>
-            <a:pPr>
-              <a:lnSpc>
-                <a:spcPct val="115000"/>
-              </a:lnSpc>
-              <a:spcAft>
-                <a:spcPts val="1300"/>
-              </a:spcAft>
-            </a:pPr>
-            <a:r>
-              <a:rPr sz="1800">
-                <a:solidFill>
-                  <a:srgbClr val="26364A"/>
-                </a:solidFill>
-                <a:latin typeface="Arial"/>
-              </a:rPr>
-              <a:t>•  Ranking dos dez piores dias</a:t>
-            </a:r>
-          </a:p>
-        </p:txBody>
-      </p:sp>
-      <p:sp>
-        <p:nvSpPr>
-          <p:cNvPr id="8" name="TextBox 7"/>
-          <p:cNvSpPr txBox="1"/>
-          <p:nvPr/>
-        </p:nvSpPr>
-        <p:spPr>
-          <a:xfrm>
             <a:off x="640080" y="6510528"/>
             <a:ext cx="5486400" cy="274320"/>
           </a:xfrm>
@@ -4536,7 +4463,7 @@
       </p:sp>
       <p:sp>
         <p:nvSpPr>
-          <p:cNvPr id="9" name="TextBox 8"/>
+          <p:cNvPr id="8" name="TextBox 7"/>
           <p:cNvSpPr txBox="1"/>
           <p:nvPr/>
         </p:nvSpPr>
@@ -4677,7 +4604,7 @@
                 </a:solidFill>
                 <a:latin typeface="Arial"/>
               </a:rPr>
-              <a:t>VISUALIZAÇÃO</a:t>
+              <a:t>ANÁLISE</a:t>
             </a:r>
           </a:p>
         </p:txBody>
@@ -4716,7 +4643,7 @@
                 </a:solidFill>
                 <a:latin typeface="Arial"/>
               </a:rPr>
-              <a:t>Dashboard AeroTrack</a:t>
+              <a:t>Indicadores calculados</a:t>
             </a:r>
           </a:p>
         </p:txBody>
@@ -4791,30 +4718,162 @@
           </a:prstGeom>
         </p:spPr>
       </p:pic>
-      <p:pic>
-        <p:nvPicPr>
-          <p:cNvPr id="7" name="Picture 6" descr="E01-dashboard-overview.png"/>
-          <p:cNvPicPr>
-            <a:picLocks noChangeAspect="1"/>
-          </p:cNvPicPr>
-          <p:nvPr/>
-        </p:nvPicPr>
-        <p:blipFill>
-          <a:blip r:embed="rId3"/>
-          <a:stretch>
-            <a:fillRect/>
-          </a:stretch>
-        </p:blipFill>
-        <p:spPr>
-          <a:xfrm>
-            <a:off x="1234440" y="1600200"/>
-            <a:ext cx="9692640" cy="11358562"/>
-          </a:xfrm>
-          <a:prstGeom prst="rect">
-            <a:avLst/>
-          </a:prstGeom>
-        </p:spPr>
-      </p:pic>
+      <p:sp>
+        <p:nvSpPr>
+          <p:cNvPr id="7" name="TextBox 6"/>
+          <p:cNvSpPr txBox="1"/>
+          <p:nvPr/>
+        </p:nvSpPr>
+        <p:spPr>
+          <a:xfrm>
+            <a:off x="822960" y="1737360"/>
+            <a:ext cx="10607040" cy="4389120"/>
+          </a:xfrm>
+          <a:prstGeom prst="rect">
+            <a:avLst/>
+          </a:prstGeom>
+          <a:noFill/>
+        </p:spPr>
+        <p:txBody>
+          <a:bodyPr wrap="square">
+            <a:spAutoFit/>
+          </a:bodyPr>
+          <a:lstStyle/>
+          <a:p>
+            <a:pPr>
+              <a:lnSpc>
+                <a:spcPct val="115000"/>
+              </a:lnSpc>
+              <a:spcAft>
+                <a:spcPts val="1300"/>
+              </a:spcAft>
+            </a:pPr>
+            <a:r>
+              <a:rPr sz="1800">
+                <a:solidFill>
+                  <a:srgbClr val="26364A"/>
+                </a:solidFill>
+                <a:latin typeface="Arial"/>
+              </a:rPr>
+              <a:t>•  Total de leituras tratadas e rejeitadas</a:t>
+            </a:r>
+          </a:p>
+          <a:p>
+            <a:pPr>
+              <a:lnSpc>
+                <a:spcPct val="115000"/>
+              </a:lnSpc>
+              <a:spcAft>
+                <a:spcPts val="1300"/>
+              </a:spcAft>
+            </a:pPr>
+            <a:r>
+              <a:rPr sz="1800">
+                <a:solidFill>
+                  <a:srgbClr val="26364A"/>
+                </a:solidFill>
+                <a:latin typeface="Arial"/>
+              </a:rPr>
+              <a:t>•  Percentual de horas em condição crítica</a:t>
+            </a:r>
+          </a:p>
+          <a:p>
+            <a:pPr>
+              <a:lnSpc>
+                <a:spcPct val="115000"/>
+              </a:lnSpc>
+              <a:spcAft>
+                <a:spcPts val="1300"/>
+              </a:spcAft>
+            </a:pPr>
+            <a:r>
+              <a:rPr sz="1800">
+                <a:solidFill>
+                  <a:srgbClr val="26364A"/>
+                </a:solidFill>
+                <a:latin typeface="Arial"/>
+              </a:rPr>
+              <a:t>•  CO e NO2 médios e máximos</a:t>
+            </a:r>
+          </a:p>
+          <a:p>
+            <a:pPr>
+              <a:lnSpc>
+                <a:spcPct val="115000"/>
+              </a:lnSpc>
+              <a:spcAft>
+                <a:spcPts val="1300"/>
+              </a:spcAft>
+            </a:pPr>
+            <a:r>
+              <a:rPr sz="1800">
+                <a:solidFill>
+                  <a:srgbClr val="26364A"/>
+                </a:solidFill>
+                <a:latin typeface="Arial"/>
+              </a:rPr>
+              <a:t>•  Evolução mensal de CO e de NO2</a:t>
+            </a:r>
+          </a:p>
+          <a:p>
+            <a:pPr>
+              <a:lnSpc>
+                <a:spcPct val="115000"/>
+              </a:lnSpc>
+              <a:spcAft>
+                <a:spcPts val="1300"/>
+              </a:spcAft>
+            </a:pPr>
+            <a:r>
+              <a:rPr sz="1800">
+                <a:solidFill>
+                  <a:srgbClr val="26364A"/>
+                </a:solidFill>
+                <a:latin typeface="Arial"/>
+              </a:rPr>
+              <a:t>•  Distribuição das leituras por nível (bom, moderado, crítico)</a:t>
+            </a:r>
+          </a:p>
+          <a:p>
+            <a:pPr>
+              <a:lnSpc>
+                <a:spcPct val="115000"/>
+              </a:lnSpc>
+              <a:spcAft>
+                <a:spcPts val="1300"/>
+              </a:spcAft>
+            </a:pPr>
+            <a:r>
+              <a:rPr sz="1800">
+                <a:solidFill>
+                  <a:srgbClr val="26364A"/>
+                </a:solidFill>
+                <a:latin typeface="Arial"/>
+              </a:rPr>
+              <a:t>•  Leituras por turno do dia</a:t>
+            </a:r>
+          </a:p>
+          <a:p>
+            <a:pPr>
+              <a:lnSpc>
+                <a:spcPct val="115000"/>
+              </a:lnSpc>
+              <a:spcAft>
+                <a:spcPts val="1300"/>
+              </a:spcAft>
+            </a:pPr>
+            <a:r>
+              <a:rPr sz="1800">
+                <a:solidFill>
+                  <a:srgbClr val="26364A"/>
+                </a:solidFill>
+                <a:latin typeface="Arial"/>
+              </a:rPr>
+              <a:t>•  Ranking dos dez piores dias</a:t>
+            </a:r>
+          </a:p>
+        </p:txBody>
+      </p:sp>
       <p:sp>
         <p:nvSpPr>
           <p:cNvPr id="8" name="TextBox 7"/>
@@ -4823,8 +4882,8 @@
         </p:nvSpPr>
         <p:spPr>
           <a:xfrm>
-            <a:off x="822960" y="6355080"/>
-            <a:ext cx="10515600" cy="365760"/>
+            <a:off x="640080" y="6510528"/>
+            <a:ext cx="5486400" cy="274320"/>
           </a:xfrm>
           <a:prstGeom prst="rect">
             <a:avLst/>
@@ -4843,13 +4902,13 @@
               </a:lnSpc>
             </a:pPr>
             <a:r>
-              <a:rPr sz="1100" b="0" i="1">
+              <a:rPr sz="1000" b="0" i="0">
                 <a:solidFill>
                   <a:srgbClr val="898781"/>
                 </a:solidFill>
                 <a:latin typeface="Arial"/>
               </a:rPr>
-              <a:t>Interface do dashboard em inglês, junto com o restante do código do projeto.</a:t>
+              <a:t>AeroTrack | Módulo 6 | Apache Hop</a:t>
             </a:r>
           </a:p>
         </p:txBody>
@@ -4857,45 +4916,6 @@
       <p:sp>
         <p:nvSpPr>
           <p:cNvPr id="9" name="TextBox 8"/>
-          <p:cNvSpPr txBox="1"/>
-          <p:nvPr/>
-        </p:nvSpPr>
-        <p:spPr>
-          <a:xfrm>
-            <a:off x="640080" y="6510528"/>
-            <a:ext cx="5486400" cy="274320"/>
-          </a:xfrm>
-          <a:prstGeom prst="rect">
-            <a:avLst/>
-          </a:prstGeom>
-          <a:noFill/>
-        </p:spPr>
-        <p:txBody>
-          <a:bodyPr wrap="square" anchor="t">
-            <a:spAutoFit/>
-          </a:bodyPr>
-          <a:lstStyle/>
-          <a:p>
-            <a:pPr algn="l">
-              <a:lnSpc>
-                <a:spcPct val="115000"/>
-              </a:lnSpc>
-            </a:pPr>
-            <a:r>
-              <a:rPr sz="1000" b="0" i="0">
-                <a:solidFill>
-                  <a:srgbClr val="898781"/>
-                </a:solidFill>
-                <a:latin typeface="Arial"/>
-              </a:rPr>
-              <a:t>AeroTrack | Módulo 6 | Apache Hop</a:t>
-            </a:r>
-          </a:p>
-        </p:txBody>
-      </p:sp>
-      <p:sp>
-        <p:nvSpPr>
-          <p:cNvPr id="10" name="TextBox 9"/>
           <p:cNvSpPr txBox="1"/>
           <p:nvPr/>
         </p:nvSpPr>
@@ -5036,7 +5056,7 @@
                 </a:solidFill>
                 <a:latin typeface="Arial"/>
               </a:rPr>
-              <a:t>RESPONDENDO À PERGUNTA</a:t>
+              <a:t>VISUALIZAÇÃO</a:t>
             </a:r>
           </a:p>
         </p:txBody>
@@ -5075,7 +5095,7 @@
                 </a:solidFill>
                 <a:latin typeface="Arial"/>
               </a:rPr>
-              <a:t>Ranking dos dez piores dias</a:t>
+              <a:t>Dashboard AeroTrack</a:t>
             </a:r>
           </a:p>
         </p:txBody>
@@ -5152,7 +5172,7 @@
       </p:pic>
       <p:pic>
         <p:nvPicPr>
-          <p:cNvPr id="7" name="Picture 6" descr="E02-dashboard-ranking.png"/>
+          <p:cNvPr id="7" name="Picture 6" descr="E01-dashboard-overview.png"/>
           <p:cNvPicPr>
             <a:picLocks noChangeAspect="1"/>
           </p:cNvPicPr>
@@ -5166,8 +5186,8 @@
         </p:blipFill>
         <p:spPr>
           <a:xfrm>
-            <a:off x="1737360" y="1737360"/>
-            <a:ext cx="8686800" cy="3053953"/>
+            <a:off x="1234440" y="1600200"/>
+            <a:ext cx="9692640" cy="11358562"/>
           </a:xfrm>
           <a:prstGeom prst="rect">
             <a:avLst/>
@@ -5182,6 +5202,45 @@
         </p:nvSpPr>
         <p:spPr>
           <a:xfrm>
+            <a:off x="822960" y="6355080"/>
+            <a:ext cx="10515600" cy="365760"/>
+          </a:xfrm>
+          <a:prstGeom prst="rect">
+            <a:avLst/>
+          </a:prstGeom>
+          <a:noFill/>
+        </p:spPr>
+        <p:txBody>
+          <a:bodyPr wrap="square" anchor="t">
+            <a:spAutoFit/>
+          </a:bodyPr>
+          <a:lstStyle/>
+          <a:p>
+            <a:pPr algn="l">
+              <a:lnSpc>
+                <a:spcPct val="115000"/>
+              </a:lnSpc>
+            </a:pPr>
+            <a:r>
+              <a:rPr sz="1100" b="0" i="1">
+                <a:solidFill>
+                  <a:srgbClr val="898781"/>
+                </a:solidFill>
+                <a:latin typeface="Arial"/>
+              </a:rPr>
+              <a:t>Interface do dashboard em inglês, junto com o restante do código do projeto.</a:t>
+            </a:r>
+          </a:p>
+        </p:txBody>
+      </p:sp>
+      <p:sp>
+        <p:nvSpPr>
+          <p:cNvPr id="9" name="TextBox 8"/>
+          <p:cNvSpPr txBox="1"/>
+          <p:nvPr/>
+        </p:nvSpPr>
+        <p:spPr>
+          <a:xfrm>
             <a:off x="640080" y="6510528"/>
             <a:ext cx="5486400" cy="274320"/>
           </a:xfrm>
@@ -5215,7 +5274,7 @@
       </p:sp>
       <p:sp>
         <p:nvSpPr>
-          <p:cNvPr id="9" name="TextBox 8"/>
+          <p:cNvPr id="10" name="TextBox 9"/>
           <p:cNvSpPr txBox="1"/>
           <p:nvPr/>
         </p:nvSpPr>
@@ -5356,6 +5415,326 @@
                 </a:solidFill>
                 <a:latin typeface="Arial"/>
               </a:rPr>
+              <a:t>RESPONDENDO À PERGUNTA</a:t>
+            </a:r>
+          </a:p>
+        </p:txBody>
+      </p:sp>
+      <p:sp>
+        <p:nvSpPr>
+          <p:cNvPr id="4" name="TextBox 3"/>
+          <p:cNvSpPr txBox="1"/>
+          <p:nvPr/>
+        </p:nvSpPr>
+        <p:spPr>
+          <a:xfrm>
+            <a:off x="640080" y="594360"/>
+            <a:ext cx="10789920" cy="822960"/>
+          </a:xfrm>
+          <a:prstGeom prst="rect">
+            <a:avLst/>
+          </a:prstGeom>
+          <a:noFill/>
+        </p:spPr>
+        <p:txBody>
+          <a:bodyPr wrap="square" anchor="t">
+            <a:spAutoFit/>
+          </a:bodyPr>
+          <a:lstStyle/>
+          <a:p>
+            <a:pPr algn="l">
+              <a:lnSpc>
+                <a:spcPct val="115000"/>
+              </a:lnSpc>
+            </a:pPr>
+            <a:r>
+              <a:rPr sz="2900" b="1" i="0">
+                <a:solidFill>
+                  <a:srgbClr val="0B1F33"/>
+                </a:solidFill>
+                <a:latin typeface="Arial"/>
+              </a:rPr>
+              <a:t>Ranking dos dez piores dias</a:t>
+            </a:r>
+          </a:p>
+        </p:txBody>
+      </p:sp>
+      <p:sp>
+        <p:nvSpPr>
+          <p:cNvPr id="5" name="Rounded Rectangle 4"/>
+          <p:cNvSpPr/>
+          <p:nvPr/>
+        </p:nvSpPr>
+        <p:spPr>
+          <a:xfrm>
+            <a:off x="658368" y="1261872"/>
+            <a:ext cx="1188720" cy="50800"/>
+          </a:xfrm>
+          <a:prstGeom prst="roundRect">
+            <a:avLst>
+              <a:gd name="adj" fmla="val 50000"/>
+            </a:avLst>
+          </a:prstGeom>
+          <a:solidFill>
+            <a:srgbClr val="1BAF7A"/>
+          </a:solidFill>
+          <a:ln>
+            <a:noFill/>
+          </a:ln>
+          <a:effectLst/>
+        </p:spPr>
+        <p:style>
+          <a:lnRef idx="1">
+            <a:schemeClr val="accent1"/>
+          </a:lnRef>
+          <a:fillRef idx="3">
+            <a:schemeClr val="accent1"/>
+          </a:fillRef>
+          <a:effectRef idx="2">
+            <a:schemeClr val="accent1"/>
+          </a:effectRef>
+          <a:fontRef idx="minor">
+            <a:schemeClr val="lt1"/>
+          </a:fontRef>
+        </p:style>
+        <p:txBody>
+          <a:bodyPr rtlCol="0" anchor="ctr"/>
+          <a:lstStyle/>
+          <a:p>
+            <a:pPr algn="ctr"/>
+          </a:p>
+        </p:txBody>
+      </p:sp>
+      <p:pic>
+        <p:nvPicPr>
+          <p:cNvPr id="6" name="Picture 5" descr="aerotrack-icon.png"/>
+          <p:cNvPicPr>
+            <a:picLocks noChangeAspect="1"/>
+          </p:cNvPicPr>
+          <p:nvPr/>
+        </p:nvPicPr>
+        <p:blipFill>
+          <a:blip r:embed="rId2"/>
+          <a:stretch>
+            <a:fillRect/>
+          </a:stretch>
+        </p:blipFill>
+        <p:spPr>
+          <a:xfrm>
+            <a:off x="11292840" y="274320"/>
+            <a:ext cx="502920" cy="502920"/>
+          </a:xfrm>
+          <a:prstGeom prst="rect">
+            <a:avLst/>
+          </a:prstGeom>
+        </p:spPr>
+      </p:pic>
+      <p:pic>
+        <p:nvPicPr>
+          <p:cNvPr id="7" name="Picture 6" descr="E02-dashboard-ranking.png"/>
+          <p:cNvPicPr>
+            <a:picLocks noChangeAspect="1"/>
+          </p:cNvPicPr>
+          <p:nvPr/>
+        </p:nvPicPr>
+        <p:blipFill>
+          <a:blip r:embed="rId3"/>
+          <a:stretch>
+            <a:fillRect/>
+          </a:stretch>
+        </p:blipFill>
+        <p:spPr>
+          <a:xfrm>
+            <a:off x="1737360" y="1737360"/>
+            <a:ext cx="8686800" cy="3053953"/>
+          </a:xfrm>
+          <a:prstGeom prst="rect">
+            <a:avLst/>
+          </a:prstGeom>
+        </p:spPr>
+      </p:pic>
+      <p:sp>
+        <p:nvSpPr>
+          <p:cNvPr id="8" name="TextBox 7"/>
+          <p:cNvSpPr txBox="1"/>
+          <p:nvPr/>
+        </p:nvSpPr>
+        <p:spPr>
+          <a:xfrm>
+            <a:off x="640080" y="6510528"/>
+            <a:ext cx="5486400" cy="274320"/>
+          </a:xfrm>
+          <a:prstGeom prst="rect">
+            <a:avLst/>
+          </a:prstGeom>
+          <a:noFill/>
+        </p:spPr>
+        <p:txBody>
+          <a:bodyPr wrap="square" anchor="t">
+            <a:spAutoFit/>
+          </a:bodyPr>
+          <a:lstStyle/>
+          <a:p>
+            <a:pPr algn="l">
+              <a:lnSpc>
+                <a:spcPct val="115000"/>
+              </a:lnSpc>
+            </a:pPr>
+            <a:r>
+              <a:rPr sz="1000" b="0" i="0">
+                <a:solidFill>
+                  <a:srgbClr val="898781"/>
+                </a:solidFill>
+                <a:latin typeface="Arial"/>
+              </a:rPr>
+              <a:t>AeroTrack | Módulo 6 | Apache Hop</a:t>
+            </a:r>
+          </a:p>
+        </p:txBody>
+      </p:sp>
+      <p:sp>
+        <p:nvSpPr>
+          <p:cNvPr id="9" name="TextBox 8"/>
+          <p:cNvSpPr txBox="1"/>
+          <p:nvPr/>
+        </p:nvSpPr>
+        <p:spPr>
+          <a:xfrm>
+            <a:off x="10972800" y="6510528"/>
+            <a:ext cx="640080" cy="274320"/>
+          </a:xfrm>
+          <a:prstGeom prst="rect">
+            <a:avLst/>
+          </a:prstGeom>
+          <a:noFill/>
+        </p:spPr>
+        <p:txBody>
+          <a:bodyPr wrap="square" anchor="t">
+            <a:spAutoFit/>
+          </a:bodyPr>
+          <a:lstStyle/>
+          <a:p>
+            <a:pPr algn="r">
+              <a:lnSpc>
+                <a:spcPct val="115000"/>
+              </a:lnSpc>
+            </a:pPr>
+            <a:r>
+              <a:rPr sz="1000" b="0" i="0">
+                <a:solidFill>
+                  <a:srgbClr val="898781"/>
+                </a:solidFill>
+                <a:latin typeface="Arial"/>
+              </a:rPr>
+              <a:t>14</a:t>
+            </a:r>
+          </a:p>
+        </p:txBody>
+      </p:sp>
+    </p:spTree>
+  </p:cSld>
+  <p:clrMapOvr>
+    <a:masterClrMapping/>
+  </p:clrMapOvr>
+</p:sld>
+</file>
+
+<file path=ppt/slides/slide15.xml><?xml version="1.0" encoding="utf-8"?>
+<p:sld xmlns:a="http://schemas.openxmlformats.org/drawingml/2006/main" xmlns:p="http://schemas.openxmlformats.org/presentationml/2006/main" xmlns:r="http://schemas.openxmlformats.org/officeDocument/2006/relationships">
+  <p:cSld>
+    <p:bg>
+      <p:bgPr>
+        <a:solidFill>
+          <a:srgbClr val="FFFFFF"/>
+        </a:solidFill>
+        <a:effectLst/>
+      </p:bgPr>
+    </p:bg>
+    <p:spTree>
+      <p:nvGrpSpPr>
+        <p:cNvPr id="1" name=""/>
+        <p:cNvGrpSpPr/>
+        <p:nvPr/>
+      </p:nvGrpSpPr>
+      <p:grpSpPr/>
+      <p:sp>
+        <p:nvSpPr>
+          <p:cNvPr id="2" name="Rectangle 1"/>
+          <p:cNvSpPr/>
+          <p:nvPr/>
+        </p:nvSpPr>
+        <p:spPr>
+          <a:xfrm>
+            <a:off x="0" y="0"/>
+            <a:ext cx="12191695" cy="128016"/>
+          </a:xfrm>
+          <a:prstGeom prst="rect">
+            <a:avLst/>
+          </a:prstGeom>
+          <a:solidFill>
+            <a:srgbClr val="2A78D6"/>
+          </a:solidFill>
+          <a:ln>
+            <a:noFill/>
+          </a:ln>
+          <a:effectLst/>
+        </p:spPr>
+        <p:style>
+          <a:lnRef idx="1">
+            <a:schemeClr val="accent1"/>
+          </a:lnRef>
+          <a:fillRef idx="3">
+            <a:schemeClr val="accent1"/>
+          </a:fillRef>
+          <a:effectRef idx="2">
+            <a:schemeClr val="accent1"/>
+          </a:effectRef>
+          <a:fontRef idx="minor">
+            <a:schemeClr val="lt1"/>
+          </a:fontRef>
+        </p:style>
+        <p:txBody>
+          <a:bodyPr rtlCol="0" anchor="ctr"/>
+          <a:lstStyle/>
+          <a:p>
+            <a:pPr algn="ctr"/>
+          </a:p>
+        </p:txBody>
+      </p:sp>
+      <p:sp>
+        <p:nvSpPr>
+          <p:cNvPr id="3" name="TextBox 2"/>
+          <p:cNvSpPr txBox="1"/>
+          <p:nvPr/>
+        </p:nvSpPr>
+        <p:spPr>
+          <a:xfrm>
+            <a:off x="640080" y="292608"/>
+            <a:ext cx="8686800" cy="365760"/>
+          </a:xfrm>
+          <a:prstGeom prst="rect">
+            <a:avLst/>
+          </a:prstGeom>
+          <a:noFill/>
+        </p:spPr>
+        <p:txBody>
+          <a:bodyPr wrap="square" anchor="t">
+            <a:spAutoFit/>
+          </a:bodyPr>
+          <a:lstStyle/>
+          <a:p>
+            <a:pPr algn="l">
+              <a:lnSpc>
+                <a:spcPct val="115000"/>
+              </a:lnSpc>
+            </a:pPr>
+            <a:r>
+              <a:rPr sz="1400" b="1" i="0">
+                <a:solidFill>
+                  <a:srgbClr val="1BAF7A"/>
+                </a:solidFill>
+                <a:latin typeface="Arial"/>
+              </a:rPr>
               <a:t>RESULTADOS</a:t>
             </a:r>
           </a:p>
@@ -6436,7 +6815,7 @@
                 </a:solidFill>
                 <a:latin typeface="Arial"/>
               </a:rPr>
-              <a:t>14</a:t>
+              <a:t>15</a:t>
             </a:r>
           </a:p>
         </p:txBody>
@@ -6449,7 +6828,7 @@
 </p:sld>
 </file>
 
-<file path=ppt/slides/slide15.xml><?xml version="1.0" encoding="utf-8"?>
+<file path=ppt/slides/slide16.xml><?xml version="1.0" encoding="utf-8"?>
 <p:sld xmlns:a="http://schemas.openxmlformats.org/drawingml/2006/main" xmlns:p="http://schemas.openxmlformats.org/presentationml/2006/main" xmlns:r="http://schemas.openxmlformats.org/officeDocument/2006/relationships">
   <p:cSld>
     <p:bg>
@@ -6705,7 +7084,7 @@
                 </a:solidFill>
                 <a:latin typeface="Arial"/>
               </a:rPr>
-              <a:t>15</a:t>
+              <a:t>16</a:t>
             </a:r>
           </a:p>
         </p:txBody>
@@ -6718,7 +7097,578 @@
 </p:sld>
 </file>
 
-<file path=ppt/slides/slide16.xml><?xml version="1.0" encoding="utf-8"?>
+<file path=ppt/slides/slide17.xml><?xml version="1.0" encoding="utf-8"?>
+<p:sld xmlns:a="http://schemas.openxmlformats.org/drawingml/2006/main" xmlns:p="http://schemas.openxmlformats.org/presentationml/2006/main" xmlns:r="http://schemas.openxmlformats.org/officeDocument/2006/relationships">
+  <p:cSld>
+    <p:bg>
+      <p:bgPr>
+        <a:solidFill>
+          <a:srgbClr val="FFFFFF"/>
+        </a:solidFill>
+        <a:effectLst/>
+      </p:bgPr>
+    </p:bg>
+    <p:spTree>
+      <p:nvGrpSpPr>
+        <p:cNvPr id="1" name=""/>
+        <p:cNvGrpSpPr/>
+        <p:nvPr/>
+      </p:nvGrpSpPr>
+      <p:grpSpPr/>
+      <p:sp>
+        <p:nvSpPr>
+          <p:cNvPr id="2" name="Rectangle 1"/>
+          <p:cNvSpPr/>
+          <p:nvPr/>
+        </p:nvSpPr>
+        <p:spPr>
+          <a:xfrm>
+            <a:off x="0" y="0"/>
+            <a:ext cx="12191695" cy="128016"/>
+          </a:xfrm>
+          <a:prstGeom prst="rect">
+            <a:avLst/>
+          </a:prstGeom>
+          <a:solidFill>
+            <a:srgbClr val="2A78D6"/>
+          </a:solidFill>
+          <a:ln>
+            <a:noFill/>
+          </a:ln>
+          <a:effectLst/>
+        </p:spPr>
+        <p:style>
+          <a:lnRef idx="1">
+            <a:schemeClr val="accent1"/>
+          </a:lnRef>
+          <a:fillRef idx="3">
+            <a:schemeClr val="accent1"/>
+          </a:fillRef>
+          <a:effectRef idx="2">
+            <a:schemeClr val="accent1"/>
+          </a:effectRef>
+          <a:fontRef idx="minor">
+            <a:schemeClr val="lt1"/>
+          </a:fontRef>
+        </p:style>
+        <p:txBody>
+          <a:bodyPr rtlCol="0" anchor="ctr"/>
+          <a:lstStyle/>
+          <a:p>
+            <a:pPr algn="ctr"/>
+          </a:p>
+        </p:txBody>
+      </p:sp>
+      <p:sp>
+        <p:nvSpPr>
+          <p:cNvPr id="3" name="TextBox 2"/>
+          <p:cNvSpPr txBox="1"/>
+          <p:nvPr/>
+        </p:nvSpPr>
+        <p:spPr>
+          <a:xfrm>
+            <a:off x="640080" y="292608"/>
+            <a:ext cx="8686800" cy="365760"/>
+          </a:xfrm>
+          <a:prstGeom prst="rect">
+            <a:avLst/>
+          </a:prstGeom>
+          <a:noFill/>
+        </p:spPr>
+        <p:txBody>
+          <a:bodyPr wrap="square" anchor="t">
+            <a:spAutoFit/>
+          </a:bodyPr>
+          <a:lstStyle/>
+          <a:p>
+            <a:pPr algn="l">
+              <a:lnSpc>
+                <a:spcPct val="115000"/>
+              </a:lnSpc>
+            </a:pPr>
+            <a:r>
+              <a:rPr sz="1400" b="1" i="0">
+                <a:solidFill>
+                  <a:srgbClr val="1BAF7A"/>
+                </a:solidFill>
+                <a:latin typeface="Arial"/>
+              </a:rPr>
+              <a:t>PARA SABER MAIS</a:t>
+            </a:r>
+          </a:p>
+        </p:txBody>
+      </p:sp>
+      <p:sp>
+        <p:nvSpPr>
+          <p:cNvPr id="4" name="TextBox 3"/>
+          <p:cNvSpPr txBox="1"/>
+          <p:nvPr/>
+        </p:nvSpPr>
+        <p:spPr>
+          <a:xfrm>
+            <a:off x="640080" y="594360"/>
+            <a:ext cx="10789920" cy="822960"/>
+          </a:xfrm>
+          <a:prstGeom prst="rect">
+            <a:avLst/>
+          </a:prstGeom>
+          <a:noFill/>
+        </p:spPr>
+        <p:txBody>
+          <a:bodyPr wrap="square" anchor="t">
+            <a:spAutoFit/>
+          </a:bodyPr>
+          <a:lstStyle/>
+          <a:p>
+            <a:pPr algn="l">
+              <a:lnSpc>
+                <a:spcPct val="115000"/>
+              </a:lnSpc>
+            </a:pPr>
+            <a:r>
+              <a:rPr sz="2900" b="1" i="0">
+                <a:solidFill>
+                  <a:srgbClr val="0B1F33"/>
+                </a:solidFill>
+                <a:latin typeface="Arial"/>
+              </a:rPr>
+              <a:t>Relatório de desenvolvimento</a:t>
+            </a:r>
+          </a:p>
+        </p:txBody>
+      </p:sp>
+      <p:sp>
+        <p:nvSpPr>
+          <p:cNvPr id="5" name="Rounded Rectangle 4"/>
+          <p:cNvSpPr/>
+          <p:nvPr/>
+        </p:nvSpPr>
+        <p:spPr>
+          <a:xfrm>
+            <a:off x="658368" y="1261872"/>
+            <a:ext cx="1188720" cy="50800"/>
+          </a:xfrm>
+          <a:prstGeom prst="roundRect">
+            <a:avLst>
+              <a:gd name="adj" fmla="val 50000"/>
+            </a:avLst>
+          </a:prstGeom>
+          <a:solidFill>
+            <a:srgbClr val="1BAF7A"/>
+          </a:solidFill>
+          <a:ln>
+            <a:noFill/>
+          </a:ln>
+          <a:effectLst/>
+        </p:spPr>
+        <p:style>
+          <a:lnRef idx="1">
+            <a:schemeClr val="accent1"/>
+          </a:lnRef>
+          <a:fillRef idx="3">
+            <a:schemeClr val="accent1"/>
+          </a:fillRef>
+          <a:effectRef idx="2">
+            <a:schemeClr val="accent1"/>
+          </a:effectRef>
+          <a:fontRef idx="minor">
+            <a:schemeClr val="lt1"/>
+          </a:fontRef>
+        </p:style>
+        <p:txBody>
+          <a:bodyPr rtlCol="0" anchor="ctr"/>
+          <a:lstStyle/>
+          <a:p>
+            <a:pPr algn="ctr"/>
+          </a:p>
+        </p:txBody>
+      </p:sp>
+      <p:pic>
+        <p:nvPicPr>
+          <p:cNvPr id="6" name="Picture 5" descr="aerotrack-icon.png"/>
+          <p:cNvPicPr>
+            <a:picLocks noChangeAspect="1"/>
+          </p:cNvPicPr>
+          <p:nvPr/>
+        </p:nvPicPr>
+        <p:blipFill>
+          <a:blip r:embed="rId2"/>
+          <a:stretch>
+            <a:fillRect/>
+          </a:stretch>
+        </p:blipFill>
+        <p:spPr>
+          <a:xfrm>
+            <a:off x="11292840" y="274320"/>
+            <a:ext cx="502920" cy="502920"/>
+          </a:xfrm>
+          <a:prstGeom prst="rect">
+            <a:avLst/>
+          </a:prstGeom>
+        </p:spPr>
+      </p:pic>
+      <p:pic>
+        <p:nvPicPr>
+          <p:cNvPr id="7" name="Picture 6" descr="report_preview.png"/>
+          <p:cNvPicPr>
+            <a:picLocks noChangeAspect="1"/>
+          </p:cNvPicPr>
+          <p:nvPr/>
+        </p:nvPicPr>
+        <p:blipFill>
+          <a:blip r:embed="rId3"/>
+          <a:stretch>
+            <a:fillRect/>
+          </a:stretch>
+        </p:blipFill>
+        <p:spPr>
+          <a:xfrm>
+            <a:off x="685800" y="1691640"/>
+            <a:ext cx="3331852" cy="4709160"/>
+          </a:xfrm>
+          <a:prstGeom prst="rect">
+            <a:avLst/>
+          </a:prstGeom>
+        </p:spPr>
+      </p:pic>
+      <p:sp>
+        <p:nvSpPr>
+          <p:cNvPr id="8" name="Rounded Rectangle 7"/>
+          <p:cNvSpPr/>
+          <p:nvPr/>
+        </p:nvSpPr>
+        <p:spPr>
+          <a:xfrm>
+            <a:off x="6903720" y="2103120"/>
+            <a:ext cx="4572000" cy="3840480"/>
+          </a:xfrm>
+          <a:prstGeom prst="roundRect">
+            <a:avLst>
+              <a:gd name="adj" fmla="val 10000"/>
+            </a:avLst>
+          </a:prstGeom>
+          <a:solidFill>
+            <a:srgbClr val="F2F7FB"/>
+          </a:solidFill>
+          <a:ln w="9525">
+            <a:solidFill>
+              <a:srgbClr val="C9D8E8"/>
+            </a:solidFill>
+          </a:ln>
+          <a:effectLst/>
+          <a:effectLst>
+            <a:outerShdw blurRad="180000" dist="45000" dir="5400000" rotWithShape="0">
+              <a:srgbClr val="0B1F33">
+                <a:alpha val="72000"/>
+              </a:srgbClr>
+            </a:outerShdw>
+          </a:effectLst>
+        </p:spPr>
+        <p:style>
+          <a:lnRef idx="1">
+            <a:schemeClr val="accent1"/>
+          </a:lnRef>
+          <a:fillRef idx="3">
+            <a:schemeClr val="accent1"/>
+          </a:fillRef>
+          <a:effectRef idx="2">
+            <a:schemeClr val="accent1"/>
+          </a:effectRef>
+          <a:fontRef idx="minor">
+            <a:schemeClr val="lt1"/>
+          </a:fontRef>
+        </p:style>
+        <p:txBody>
+          <a:bodyPr rtlCol="0" anchor="ctr"/>
+          <a:lstStyle/>
+          <a:p>
+            <a:pPr algn="ctr"/>
+          </a:p>
+        </p:txBody>
+      </p:sp>
+      <p:sp>
+        <p:nvSpPr>
+          <p:cNvPr id="9" name="TextBox 8"/>
+          <p:cNvSpPr txBox="1"/>
+          <p:nvPr/>
+        </p:nvSpPr>
+        <p:spPr>
+          <a:xfrm>
+            <a:off x="7178040" y="2331720"/>
+            <a:ext cx="4023360" cy="457200"/>
+          </a:xfrm>
+          <a:prstGeom prst="rect">
+            <a:avLst/>
+          </a:prstGeom>
+          <a:noFill/>
+        </p:spPr>
+        <p:txBody>
+          <a:bodyPr wrap="square" anchor="t">
+            <a:spAutoFit/>
+          </a:bodyPr>
+          <a:lstStyle/>
+          <a:p>
+            <a:pPr algn="l">
+              <a:lnSpc>
+                <a:spcPct val="115000"/>
+              </a:lnSpc>
+            </a:pPr>
+            <a:r>
+              <a:rPr sz="1300" b="1" i="0">
+                <a:solidFill>
+                  <a:srgbClr val="1BAF7A"/>
+                </a:solidFill>
+                <a:latin typeface="Arial"/>
+              </a:rPr>
+              <a:t>23 PÁGINAS</a:t>
+            </a:r>
+          </a:p>
+        </p:txBody>
+      </p:sp>
+      <p:sp>
+        <p:nvSpPr>
+          <p:cNvPr id="10" name="TextBox 9"/>
+          <p:cNvSpPr txBox="1"/>
+          <p:nvPr/>
+        </p:nvSpPr>
+        <p:spPr>
+          <a:xfrm>
+            <a:off x="7178040" y="2743200"/>
+            <a:ext cx="4023360" cy="3017520"/>
+          </a:xfrm>
+          <a:prstGeom prst="rect">
+            <a:avLst/>
+          </a:prstGeom>
+          <a:noFill/>
+        </p:spPr>
+        <p:txBody>
+          <a:bodyPr wrap="square">
+            <a:spAutoFit/>
+          </a:bodyPr>
+          <a:lstStyle/>
+          <a:p>
+            <a:pPr>
+              <a:lnSpc>
+                <a:spcPct val="115000"/>
+              </a:lnSpc>
+              <a:spcAft>
+                <a:spcPts val="1200"/>
+              </a:spcAft>
+            </a:pPr>
+            <a:r>
+              <a:rPr sz="1400">
+                <a:solidFill>
+                  <a:srgbClr val="26364A"/>
+                </a:solidFill>
+                <a:latin typeface="Arial"/>
+              </a:rPr>
+              <a:t>•  Arquitetura, pipelines e workflow em detalhe</a:t>
+            </a:r>
+          </a:p>
+          <a:p>
+            <a:pPr>
+              <a:lnSpc>
+                <a:spcPct val="115000"/>
+              </a:lnSpc>
+              <a:spcAft>
+                <a:spcPts val="1200"/>
+              </a:spcAft>
+            </a:pPr>
+            <a:r>
+              <a:rPr sz="1400">
+                <a:solidFill>
+                  <a:srgbClr val="26364A"/>
+                </a:solidFill>
+                <a:latin typeface="Arial"/>
+              </a:rPr>
+              <a:t>•  Tratamento de dados e ajustes técnicos</a:t>
+            </a:r>
+          </a:p>
+          <a:p>
+            <a:pPr>
+              <a:lnSpc>
+                <a:spcPct val="115000"/>
+              </a:lnSpc>
+              <a:spcAft>
+                <a:spcPts val="1200"/>
+              </a:spcAft>
+            </a:pPr>
+            <a:r>
+              <a:rPr sz="1400">
+                <a:solidFill>
+                  <a:srgbClr val="26364A"/>
+                </a:solidFill>
+                <a:latin typeface="Arial"/>
+              </a:rPr>
+              <a:t>•  Contrato do banco de dados</a:t>
+            </a:r>
+          </a:p>
+          <a:p>
+            <a:pPr>
+              <a:lnSpc>
+                <a:spcPct val="115000"/>
+              </a:lnSpc>
+              <a:spcAft>
+                <a:spcPts val="1200"/>
+              </a:spcAft>
+            </a:pPr>
+            <a:r>
+              <a:rPr sz="1400">
+                <a:solidFill>
+                  <a:srgbClr val="26364A"/>
+                </a:solidFill>
+                <a:latin typeface="Arial"/>
+              </a:rPr>
+              <a:t>•  Indicadores, dashboard e validação dos resultados</a:t>
+            </a:r>
+          </a:p>
+          <a:p>
+            <a:pPr>
+              <a:lnSpc>
+                <a:spcPct val="115000"/>
+              </a:lnSpc>
+              <a:spcAft>
+                <a:spcPts val="1200"/>
+              </a:spcAft>
+            </a:pPr>
+            <a:r>
+              <a:rPr sz="1400">
+                <a:solidFill>
+                  <a:srgbClr val="26364A"/>
+                </a:solidFill>
+                <a:latin typeface="Arial"/>
+              </a:rPr>
+              <a:t>•  Manual de replicação passo a passo</a:t>
+            </a:r>
+          </a:p>
+        </p:txBody>
+      </p:sp>
+      <p:sp>
+        <p:nvSpPr>
+          <p:cNvPr id="11" name="TextBox 10"/>
+          <p:cNvSpPr txBox="1"/>
+          <p:nvPr/>
+        </p:nvSpPr>
+        <p:spPr>
+          <a:xfrm>
+            <a:off x="7178040" y="5623560"/>
+            <a:ext cx="4023360" cy="548640"/>
+          </a:xfrm>
+          <a:prstGeom prst="rect">
+            <a:avLst/>
+          </a:prstGeom>
+          <a:noFill/>
+        </p:spPr>
+        <p:txBody>
+          <a:bodyPr wrap="square" anchor="t">
+            <a:spAutoFit/>
+          </a:bodyPr>
+          <a:lstStyle/>
+          <a:p>
+            <a:pPr algn="l">
+              <a:lnSpc>
+                <a:spcPct val="115000"/>
+              </a:lnSpc>
+            </a:pPr>
+            <a:r>
+              <a:rPr sz="1100" b="0" i="1">
+                <a:solidFill>
+                  <a:srgbClr val="898781"/>
+                </a:solidFill>
+                <a:latin typeface="Arial"/>
+              </a:rPr>
+              <a:t>docs/evidencias/relatorio-desenvolvimento-aerotrack.pdf</a:t>
+            </a:r>
+          </a:p>
+        </p:txBody>
+      </p:sp>
+      <p:sp>
+        <p:nvSpPr>
+          <p:cNvPr id="12" name="TextBox 11"/>
+          <p:cNvSpPr txBox="1"/>
+          <p:nvPr/>
+        </p:nvSpPr>
+        <p:spPr>
+          <a:xfrm>
+            <a:off x="640080" y="6510528"/>
+            <a:ext cx="5486400" cy="274320"/>
+          </a:xfrm>
+          <a:prstGeom prst="rect">
+            <a:avLst/>
+          </a:prstGeom>
+          <a:noFill/>
+        </p:spPr>
+        <p:txBody>
+          <a:bodyPr wrap="square" anchor="t">
+            <a:spAutoFit/>
+          </a:bodyPr>
+          <a:lstStyle/>
+          <a:p>
+            <a:pPr algn="l">
+              <a:lnSpc>
+                <a:spcPct val="115000"/>
+              </a:lnSpc>
+            </a:pPr>
+            <a:r>
+              <a:rPr sz="1000" b="0" i="0">
+                <a:solidFill>
+                  <a:srgbClr val="898781"/>
+                </a:solidFill>
+                <a:latin typeface="Arial"/>
+              </a:rPr>
+              <a:t>AeroTrack | Módulo 6 | Apache Hop</a:t>
+            </a:r>
+          </a:p>
+        </p:txBody>
+      </p:sp>
+      <p:sp>
+        <p:nvSpPr>
+          <p:cNvPr id="13" name="TextBox 12"/>
+          <p:cNvSpPr txBox="1"/>
+          <p:nvPr/>
+        </p:nvSpPr>
+        <p:spPr>
+          <a:xfrm>
+            <a:off x="10972800" y="6510528"/>
+            <a:ext cx="640080" cy="274320"/>
+          </a:xfrm>
+          <a:prstGeom prst="rect">
+            <a:avLst/>
+          </a:prstGeom>
+          <a:noFill/>
+        </p:spPr>
+        <p:txBody>
+          <a:bodyPr wrap="square" anchor="t">
+            <a:spAutoFit/>
+          </a:bodyPr>
+          <a:lstStyle/>
+          <a:p>
+            <a:pPr algn="r">
+              <a:lnSpc>
+                <a:spcPct val="115000"/>
+              </a:lnSpc>
+            </a:pPr>
+            <a:r>
+              <a:rPr sz="1000" b="0" i="0">
+                <a:solidFill>
+                  <a:srgbClr val="898781"/>
+                </a:solidFill>
+                <a:latin typeface="Arial"/>
+              </a:rPr>
+              <a:t>17</a:t>
+            </a:r>
+          </a:p>
+        </p:txBody>
+      </p:sp>
+    </p:spTree>
+  </p:cSld>
+  <p:clrMapOvr>
+    <a:masterClrMapping/>
+  </p:clrMapOvr>
+</p:sld>
+</file>
+
+<file path=ppt/slides/slide18.xml><?xml version="1.0" encoding="utf-8"?>
 <p:sld xmlns:a="http://schemas.openxmlformats.org/drawingml/2006/main" xmlns:p="http://schemas.openxmlformats.org/presentationml/2006/main" xmlns:r="http://schemas.openxmlformats.org/officeDocument/2006/relationships">
   <p:cSld>
     <p:bg>
@@ -8477,7 +9427,7 @@
         </p:blipFill>
         <p:spPr>
           <a:xfrm>
-            <a:off x="3566160" y="2286000"/>
+            <a:off x="4421124" y="2286000"/>
             <a:ext cx="3350260" cy="914400"/>
           </a:xfrm>
           <a:prstGeom prst="rect">

</xml_diff>

<commit_message>
docs(apresentacao): show cover and table of contents side by side
Replaces the single resumo-executivo preview on the report slide with
the cover and sumário pages side by side, each labeled, keeping the
page-count/legend box unchanged on the right.
</commit_message>
<xml_diff>
--- a/docs/evidencias/AeroTrack-Apresentacao-Modulo6.pptx
+++ b/docs/evidencias/AeroTrack-Apresentacao-Modulo6.pptx
@@ -7309,7 +7309,7 @@
       </p:pic>
       <p:pic>
         <p:nvPicPr>
-          <p:cNvPr id="7" name="Picture 6" descr="report_preview.png"/>
+          <p:cNvPr id="7" name="Picture 6" descr="report_cover.png"/>
           <p:cNvPicPr>
             <a:picLocks noChangeAspect="1"/>
           </p:cNvPicPr>
@@ -7323,17 +7323,119 @@
         </p:blipFill>
         <p:spPr>
           <a:xfrm>
-            <a:off x="685800" y="1691640"/>
-            <a:ext cx="3331852" cy="4709160"/>
+            <a:off x="502920" y="1691640"/>
+            <a:ext cx="2908495" cy="4114800"/>
           </a:xfrm>
           <a:prstGeom prst="rect">
             <a:avLst/>
           </a:prstGeom>
         </p:spPr>
       </p:pic>
-      <p:sp>
-        <p:nvSpPr>
-          <p:cNvPr id="8" name="Rounded Rectangle 7"/>
+      <p:pic>
+        <p:nvPicPr>
+          <p:cNvPr id="8" name="Picture 7" descr="report_sumario.png"/>
+          <p:cNvPicPr>
+            <a:picLocks noChangeAspect="1"/>
+          </p:cNvPicPr>
+          <p:nvPr/>
+        </p:nvPicPr>
+        <p:blipFill>
+          <a:blip r:embed="rId4"/>
+          <a:stretch>
+            <a:fillRect/>
+          </a:stretch>
+        </p:blipFill>
+        <p:spPr>
+          <a:xfrm>
+            <a:off x="3685735" y="1691640"/>
+            <a:ext cx="2908495" cy="4114800"/>
+          </a:xfrm>
+          <a:prstGeom prst="rect">
+            <a:avLst/>
+          </a:prstGeom>
+        </p:spPr>
+      </p:pic>
+      <p:sp>
+        <p:nvSpPr>
+          <p:cNvPr id="9" name="TextBox 8"/>
+          <p:cNvSpPr txBox="1"/>
+          <p:nvPr/>
+        </p:nvSpPr>
+        <p:spPr>
+          <a:xfrm>
+            <a:off x="502920" y="5879592"/>
+            <a:ext cx="2908495" cy="320040"/>
+          </a:xfrm>
+          <a:prstGeom prst="rect">
+            <a:avLst/>
+          </a:prstGeom>
+          <a:noFill/>
+        </p:spPr>
+        <p:txBody>
+          <a:bodyPr wrap="square" anchor="t">
+            <a:spAutoFit/>
+          </a:bodyPr>
+          <a:lstStyle/>
+          <a:p>
+            <a:pPr algn="ctr">
+              <a:lnSpc>
+                <a:spcPct val="115000"/>
+              </a:lnSpc>
+            </a:pPr>
+            <a:r>
+              <a:rPr sz="1200" b="0" i="0">
+                <a:solidFill>
+                  <a:srgbClr val="898781"/>
+                </a:solidFill>
+                <a:latin typeface="Arial"/>
+              </a:rPr>
+              <a:t>Capa</a:t>
+            </a:r>
+          </a:p>
+        </p:txBody>
+      </p:sp>
+      <p:sp>
+        <p:nvSpPr>
+          <p:cNvPr id="10" name="TextBox 9"/>
+          <p:cNvSpPr txBox="1"/>
+          <p:nvPr/>
+        </p:nvSpPr>
+        <p:spPr>
+          <a:xfrm>
+            <a:off x="3685735" y="5879592"/>
+            <a:ext cx="2908495" cy="320040"/>
+          </a:xfrm>
+          <a:prstGeom prst="rect">
+            <a:avLst/>
+          </a:prstGeom>
+          <a:noFill/>
+        </p:spPr>
+        <p:txBody>
+          <a:bodyPr wrap="square" anchor="t">
+            <a:spAutoFit/>
+          </a:bodyPr>
+          <a:lstStyle/>
+          <a:p>
+            <a:pPr algn="ctr">
+              <a:lnSpc>
+                <a:spcPct val="115000"/>
+              </a:lnSpc>
+            </a:pPr>
+            <a:r>
+              <a:rPr sz="1200" b="0" i="0">
+                <a:solidFill>
+                  <a:srgbClr val="898781"/>
+                </a:solidFill>
+                <a:latin typeface="Arial"/>
+              </a:rPr>
+              <a:t>Sumário</a:t>
+            </a:r>
+          </a:p>
+        </p:txBody>
+      </p:sp>
+      <p:sp>
+        <p:nvSpPr>
+          <p:cNvPr id="11" name="Rounded Rectangle 10"/>
           <p:cNvSpPr/>
           <p:nvPr/>
         </p:nvSpPr>
@@ -7388,7 +7490,7 @@
       </p:sp>
       <p:sp>
         <p:nvSpPr>
-          <p:cNvPr id="9" name="TextBox 8"/>
+          <p:cNvPr id="12" name="TextBox 11"/>
           <p:cNvSpPr txBox="1"/>
           <p:nvPr/>
         </p:nvSpPr>
@@ -7427,7 +7529,7 @@
       </p:sp>
       <p:sp>
         <p:nvSpPr>
-          <p:cNvPr id="10" name="TextBox 9"/>
+          <p:cNvPr id="13" name="TextBox 12"/>
           <p:cNvSpPr txBox="1"/>
           <p:nvPr/>
         </p:nvSpPr>
@@ -7545,7 +7647,7 @@
       </p:sp>
       <p:sp>
         <p:nvSpPr>
-          <p:cNvPr id="11" name="TextBox 10"/>
+          <p:cNvPr id="14" name="TextBox 13"/>
           <p:cNvSpPr txBox="1"/>
           <p:nvPr/>
         </p:nvSpPr>
@@ -7584,7 +7686,7 @@
       </p:sp>
       <p:sp>
         <p:nvSpPr>
-          <p:cNvPr id="12" name="TextBox 11"/>
+          <p:cNvPr id="15" name="TextBox 14"/>
           <p:cNvSpPr txBox="1"/>
           <p:nvPr/>
         </p:nvSpPr>
@@ -7623,7 +7725,7 @@
       </p:sp>
       <p:sp>
         <p:nvSpPr>
-          <p:cNvPr id="13" name="TextBox 12"/>
+          <p:cNvPr id="16" name="TextBox 15"/>
           <p:cNvSpPr txBox="1"/>
           <p:nvPr/>
         </p:nvSpPr>

</xml_diff>

<commit_message>
docs(apresentacao): soften screenshot corners and drop the yellow frame
Reduce the corner radius on the wide dashboard screenshots and remove
the amber frame from every picture in the presentation, then refresh
the embedded dashboard screenshots to match the redesigned dashboard.
</commit_message>
<xml_diff>
--- a/docs/evidencias/AeroTrack-Apresentacao-Modulo6.pptx
+++ b/docs/evidencias/AeroTrack-Apresentacao-Modulo6.pptx
@@ -5187,11 +5187,20 @@
         <p:spPr>
           <a:xfrm>
             <a:off x="1234440" y="1600200"/>
-            <a:ext cx="9692640" cy="11358562"/>
-          </a:xfrm>
-          <a:prstGeom prst="rect">
-            <a:avLst/>
-          </a:prstGeom>
+            <a:ext cx="9692640" cy="10601325"/>
+          </a:xfrm>
+          <a:prstGeom prst="roundRect">
+            <a:avLst>
+              <a:gd name="adj" fmla="val 4000"/>
+            </a:avLst>
+          </a:prstGeom>
+          <a:effectLst>
+            <a:outerShdw blurRad="90000" dist="22000" dir="5400000" rotWithShape="0">
+              <a:srgbClr val="0B1F33">
+                <a:alpha val="50000"/>
+              </a:srgbClr>
+            </a:outerShdw>
+          </a:effectLst>
         </p:spPr>
       </p:pic>
       <p:sp>
@@ -5548,9 +5557,18 @@
             <a:off x="1737360" y="1737360"/>
             <a:ext cx="8686800" cy="3053953"/>
           </a:xfrm>
-          <a:prstGeom prst="rect">
-            <a:avLst/>
-          </a:prstGeom>
+          <a:prstGeom prst="roundRect">
+            <a:avLst>
+              <a:gd name="adj" fmla="val 4000"/>
+            </a:avLst>
+          </a:prstGeom>
+          <a:effectLst>
+            <a:outerShdw blurRad="90000" dist="22000" dir="5400000" rotWithShape="0">
+              <a:srgbClr val="0B1F33">
+                <a:alpha val="50000"/>
+              </a:srgbClr>
+            </a:outerShdw>
+          </a:effectLst>
         </p:spPr>
       </p:pic>
       <p:sp>
@@ -7326,9 +7344,18 @@
             <a:off x="502920" y="1691640"/>
             <a:ext cx="2908495" cy="4114800"/>
           </a:xfrm>
-          <a:prstGeom prst="rect">
-            <a:avLst/>
-          </a:prstGeom>
+          <a:prstGeom prst="roundRect">
+            <a:avLst>
+              <a:gd name="adj" fmla="val 10000"/>
+            </a:avLst>
+          </a:prstGeom>
+          <a:effectLst>
+            <a:outerShdw blurRad="90000" dist="22000" dir="5400000" rotWithShape="0">
+              <a:srgbClr val="0B1F33">
+                <a:alpha val="50000"/>
+              </a:srgbClr>
+            </a:outerShdw>
+          </a:effectLst>
         </p:spPr>
       </p:pic>
       <p:pic>
@@ -7350,9 +7377,18 @@
             <a:off x="3685735" y="1691640"/>
             <a:ext cx="2908495" cy="4114800"/>
           </a:xfrm>
-          <a:prstGeom prst="rect">
-            <a:avLst/>
-          </a:prstGeom>
+          <a:prstGeom prst="roundRect">
+            <a:avLst>
+              <a:gd name="adj" fmla="val 10000"/>
+            </a:avLst>
+          </a:prstGeom>
+          <a:effectLst>
+            <a:outerShdw blurRad="90000" dist="22000" dir="5400000" rotWithShape="0">
+              <a:srgbClr val="0B1F33">
+                <a:alpha val="50000"/>
+              </a:srgbClr>
+            </a:outerShdw>
+          </a:effectLst>
         </p:spPr>
       </p:pic>
       <p:sp>

</xml_diff>

<commit_message>
docs(apresentacao): add a slide for the theme and language toggles
Insert a slide before the closing credits showing the dashboard in
light theme and Portuguese, so the presentation also demonstrates the
new toggles instead of only the dark English overview.
</commit_message>
<xml_diff>
--- a/docs/evidencias/AeroTrack-Apresentacao-Modulo6.pptx
+++ b/docs/evidencias/AeroTrack-Apresentacao-Modulo6.pptx
@@ -22,6 +22,7 @@
     <p:sldId id="270" r:id="rId21"/>
     <p:sldId id="271" r:id="rId22"/>
     <p:sldId id="272" r:id="rId23"/>
+    <p:sldId id="274" r:id="rId25"/>
     <p:sldId id="273" r:id="rId24"/>
   </p:sldIdLst>
   <p:sldSz cx="12191695" cy="6858000" type="screen4x3"/>
@@ -8348,6 +8349,374 @@
                 <a:latin typeface="Arial"/>
               </a:rPr>
               <a:t>Obrigado</a:t>
+            </a:r>
+          </a:p>
+        </p:txBody>
+      </p:sp>
+    </p:spTree>
+  </p:cSld>
+  <p:clrMapOvr>
+    <a:masterClrMapping/>
+  </p:clrMapOvr>
+</p:sld>
+</file>
+
+<file path=ppt/slides/slide19.xml><?xml version="1.0" encoding="utf-8"?>
+<p:sld xmlns:a="http://schemas.openxmlformats.org/drawingml/2006/main" xmlns:p="http://schemas.openxmlformats.org/presentationml/2006/main" xmlns:r="http://schemas.openxmlformats.org/officeDocument/2006/relationships">
+  <p:cSld>
+    <p:bg>
+      <p:bgPr>
+        <a:solidFill>
+          <a:srgbClr val="FFFFFF"/>
+        </a:solidFill>
+        <a:effectLst/>
+      </p:bgPr>
+    </p:bg>
+    <p:spTree>
+      <p:nvGrpSpPr>
+        <p:cNvPr id="1" name=""/>
+        <p:cNvGrpSpPr/>
+        <p:nvPr/>
+      </p:nvGrpSpPr>
+      <p:grpSpPr/>
+      <p:sp>
+        <p:nvSpPr>
+          <p:cNvPr id="2" name="Rectangle 1"/>
+          <p:cNvSpPr/>
+          <p:nvPr/>
+        </p:nvSpPr>
+        <p:spPr>
+          <a:xfrm>
+            <a:off x="0" y="0"/>
+            <a:ext cx="12191695" cy="128016"/>
+          </a:xfrm>
+          <a:prstGeom prst="rect">
+            <a:avLst/>
+          </a:prstGeom>
+          <a:solidFill>
+            <a:srgbClr val="2A78D6"/>
+          </a:solidFill>
+          <a:ln>
+            <a:noFill/>
+          </a:ln>
+          <a:effectLst/>
+        </p:spPr>
+        <p:style>
+          <a:lnRef idx="1">
+            <a:schemeClr val="accent1"/>
+          </a:lnRef>
+          <a:fillRef idx="3">
+            <a:schemeClr val="accent1"/>
+          </a:fillRef>
+          <a:effectRef idx="2">
+            <a:schemeClr val="accent1"/>
+          </a:effectRef>
+          <a:fontRef idx="minor">
+            <a:schemeClr val="lt1"/>
+          </a:fontRef>
+        </p:style>
+        <p:txBody>
+          <a:bodyPr rtlCol="0" anchor="ctr"/>
+          <a:lstStyle/>
+          <a:p>
+            <a:pPr algn="ctr"/>
+          </a:p>
+        </p:txBody>
+      </p:sp>
+      <p:sp>
+        <p:nvSpPr>
+          <p:cNvPr id="3" name="TextBox 2"/>
+          <p:cNvSpPr txBox="1"/>
+          <p:nvPr/>
+        </p:nvSpPr>
+        <p:spPr>
+          <a:xfrm>
+            <a:off x="640080" y="292608"/>
+            <a:ext cx="8686800" cy="365760"/>
+          </a:xfrm>
+          <a:prstGeom prst="rect">
+            <a:avLst/>
+          </a:prstGeom>
+          <a:noFill/>
+        </p:spPr>
+        <p:txBody>
+          <a:bodyPr wrap="square" anchor="t">
+            <a:spAutoFit/>
+          </a:bodyPr>
+          <a:lstStyle/>
+          <a:p>
+            <a:pPr algn="l">
+              <a:lnSpc>
+                <a:spcPct val="115000"/>
+              </a:lnSpc>
+            </a:pPr>
+            <a:r>
+              <a:rPr sz="1400" b="1" i="0">
+                <a:solidFill>
+                  <a:srgbClr val="1BAF7A"/>
+                </a:solidFill>
+                <a:latin typeface="Arial"/>
+              </a:rPr>
+              <a:t>VISUALIZAÇÃO</a:t>
+            </a:r>
+          </a:p>
+        </p:txBody>
+      </p:sp>
+      <p:sp>
+        <p:nvSpPr>
+          <p:cNvPr id="4" name="TextBox 3"/>
+          <p:cNvSpPr txBox="1"/>
+          <p:nvPr/>
+        </p:nvSpPr>
+        <p:spPr>
+          <a:xfrm>
+            <a:off x="640080" y="594360"/>
+            <a:ext cx="10789920" cy="822960"/>
+          </a:xfrm>
+          <a:prstGeom prst="rect">
+            <a:avLst/>
+          </a:prstGeom>
+          <a:noFill/>
+        </p:spPr>
+        <p:txBody>
+          <a:bodyPr wrap="square" anchor="t">
+            <a:spAutoFit/>
+          </a:bodyPr>
+          <a:lstStyle/>
+          <a:p>
+            <a:pPr algn="l">
+              <a:lnSpc>
+                <a:spcPct val="115000"/>
+              </a:lnSpc>
+            </a:pPr>
+            <a:r>
+              <a:rPr sz="2900" b="1" i="0">
+                <a:solidFill>
+                  <a:srgbClr val="0B1F33"/>
+                </a:solidFill>
+                <a:latin typeface="Arial"/>
+              </a:rPr>
+              <a:t>Tema claro, idioma e mais recursos</a:t>
+            </a:r>
+          </a:p>
+        </p:txBody>
+      </p:sp>
+      <p:sp>
+        <p:nvSpPr>
+          <p:cNvPr id="5" name="Rounded Rectangle 4"/>
+          <p:cNvSpPr/>
+          <p:nvPr/>
+        </p:nvSpPr>
+        <p:spPr>
+          <a:xfrm>
+            <a:off x="658368" y="1261872"/>
+            <a:ext cx="1188720" cy="50800"/>
+          </a:xfrm>
+          <a:prstGeom prst="roundRect">
+            <a:avLst>
+              <a:gd name="adj" fmla="val 50000"/>
+            </a:avLst>
+          </a:prstGeom>
+          <a:solidFill>
+            <a:srgbClr val="1BAF7A"/>
+          </a:solidFill>
+          <a:ln>
+            <a:noFill/>
+          </a:ln>
+          <a:effectLst/>
+        </p:spPr>
+        <p:style>
+          <a:lnRef idx="1">
+            <a:schemeClr val="accent1"/>
+          </a:lnRef>
+          <a:fillRef idx="3">
+            <a:schemeClr val="accent1"/>
+          </a:fillRef>
+          <a:effectRef idx="2">
+            <a:schemeClr val="accent1"/>
+          </a:effectRef>
+          <a:fontRef idx="minor">
+            <a:schemeClr val="lt1"/>
+          </a:fontRef>
+        </p:style>
+        <p:txBody>
+          <a:bodyPr rtlCol="0" anchor="ctr"/>
+          <a:lstStyle/>
+          <a:p>
+            <a:pPr algn="ctr"/>
+          </a:p>
+        </p:txBody>
+      </p:sp>
+      <p:pic>
+        <p:nvPicPr>
+          <p:cNvPr id="6" name="Picture 5" descr="aerotrack-icon.png"/>
+          <p:cNvPicPr>
+            <a:picLocks noChangeAspect="1"/>
+          </p:cNvPicPr>
+          <p:nvPr/>
+        </p:nvPicPr>
+        <p:blipFill>
+          <a:blip r:embed="rId2"/>
+          <a:stretch>
+            <a:fillRect/>
+          </a:stretch>
+        </p:blipFill>
+        <p:spPr>
+          <a:xfrm>
+            <a:off x="11292840" y="274320"/>
+            <a:ext cx="502920" cy="502920"/>
+          </a:xfrm>
+          <a:prstGeom prst="rect">
+            <a:avLst/>
+          </a:prstGeom>
+        </p:spPr>
+      </p:pic>
+      <p:pic>
+        <p:nvPicPr>
+          <p:cNvPr id="7" name="Picture 6" descr="E13-dashboard-light-theme-pt.png"/>
+          <p:cNvPicPr>
+            <a:picLocks noChangeAspect="1"/>
+          </p:cNvPicPr>
+          <p:nvPr/>
+        </p:nvPicPr>
+        <p:blipFill>
+          <a:blip r:embed="rId3"/>
+          <a:stretch>
+            <a:fillRect/>
+          </a:stretch>
+        </p:blipFill>
+        <p:spPr>
+          <a:xfrm>
+            <a:off x="1234440" y="1600200"/>
+            <a:ext cx="9692640" cy="10601325"/>
+          </a:xfrm>
+          <a:prstGeom prst="roundRect">
+            <a:avLst>
+              <a:gd name="adj" fmla="val 4000"/>
+            </a:avLst>
+          </a:prstGeom>
+          <a:effectLst>
+            <a:outerShdw blurRad="90000" dist="22000" dir="5400000" rotWithShape="0">
+              <a:srgbClr val="0B1F33">
+                <a:alpha val="50000"/>
+              </a:srgbClr>
+            </a:outerShdw>
+          </a:effectLst>
+        </p:spPr>
+      </p:pic>
+      <p:sp>
+        <p:nvSpPr>
+          <p:cNvPr id="8" name="TextBox 7"/>
+          <p:cNvSpPr txBox="1"/>
+          <p:nvPr/>
+        </p:nvSpPr>
+        <p:spPr>
+          <a:xfrm>
+            <a:off x="822960" y="6355080"/>
+            <a:ext cx="10515600" cy="365760"/>
+          </a:xfrm>
+          <a:prstGeom prst="rect">
+            <a:avLst/>
+          </a:prstGeom>
+          <a:noFill/>
+        </p:spPr>
+        <p:txBody>
+          <a:bodyPr wrap="square" anchor="t">
+            <a:spAutoFit/>
+          </a:bodyPr>
+          <a:lstStyle/>
+          <a:p>
+            <a:pPr algn="l">
+              <a:lnSpc>
+                <a:spcPct val="115000"/>
+              </a:lnSpc>
+            </a:pPr>
+            <a:r>
+              <a:rPr sz="1100" b="0" i="1">
+                <a:solidFill>
+                  <a:srgbClr val="898781"/>
+                </a:solidFill>
+                <a:latin typeface="Arial"/>
+              </a:rPr>
+              <a:t>Alternância de tema claro/escuro, idioma inglês/português e mapa de densidade mensal.</a:t>
+            </a:r>
+          </a:p>
+        </p:txBody>
+      </p:sp>
+      <p:sp>
+        <p:nvSpPr>
+          <p:cNvPr id="9" name="TextBox 8"/>
+          <p:cNvSpPr txBox="1"/>
+          <p:nvPr/>
+        </p:nvSpPr>
+        <p:spPr>
+          <a:xfrm>
+            <a:off x="640080" y="6510528"/>
+            <a:ext cx="5486400" cy="274320"/>
+          </a:xfrm>
+          <a:prstGeom prst="rect">
+            <a:avLst/>
+          </a:prstGeom>
+          <a:noFill/>
+        </p:spPr>
+        <p:txBody>
+          <a:bodyPr wrap="square" anchor="t">
+            <a:spAutoFit/>
+          </a:bodyPr>
+          <a:lstStyle/>
+          <a:p>
+            <a:pPr algn="l">
+              <a:lnSpc>
+                <a:spcPct val="115000"/>
+              </a:lnSpc>
+            </a:pPr>
+            <a:r>
+              <a:rPr sz="1000" b="0" i="0">
+                <a:solidFill>
+                  <a:srgbClr val="898781"/>
+                </a:solidFill>
+                <a:latin typeface="Arial"/>
+              </a:rPr>
+              <a:t>AeroTrack | Módulo 6 | Apache Hop</a:t>
+            </a:r>
+          </a:p>
+        </p:txBody>
+      </p:sp>
+      <p:sp>
+        <p:nvSpPr>
+          <p:cNvPr id="10" name="TextBox 9"/>
+          <p:cNvSpPr txBox="1"/>
+          <p:nvPr/>
+        </p:nvSpPr>
+        <p:spPr>
+          <a:xfrm>
+            <a:off x="10972800" y="6510528"/>
+            <a:ext cx="640080" cy="274320"/>
+          </a:xfrm>
+          <a:prstGeom prst="rect">
+            <a:avLst/>
+          </a:prstGeom>
+          <a:noFill/>
+        </p:spPr>
+        <p:txBody>
+          <a:bodyPr wrap="square" anchor="t">
+            <a:spAutoFit/>
+          </a:bodyPr>
+          <a:lstStyle/>
+          <a:p>
+            <a:pPr algn="r">
+              <a:lnSpc>
+                <a:spcPct val="115000"/>
+              </a:lnSpc>
+            </a:pPr>
+            <a:r>
+              <a:rPr sz="1000" b="0" i="0">
+                <a:solidFill>
+                  <a:srgbClr val="898781"/>
+                </a:solidFill>
+                <a:latin typeface="Arial"/>
+              </a:rPr>
+              <a:t>18</a:t>
             </a:r>
           </a:p>
         </p:txBody>

</xml_diff>